<commit_message>
Match AG News deliverables to reference style
</commit_message>
<xml_diff>
--- a/Term Project/deliverables/ag_news_lstm_transformer_presentation.pptx
+++ b/Term Project/deliverables/ag_news_lstm_transformer_presentation.pptx
@@ -15,8 +15,9 @@
     <p:sldId id="263" r:id="rId14"/>
     <p:sldId id="264" r:id="rId15"/>
     <p:sldId id="265" r:id="rId16"/>
+    <p:sldId id="266" r:id="rId17"/>
   </p:sldIdLst>
-  <p:sldSz cx="12191695" cy="6858000" type="screen4x3"/>
+  <p:sldSz cx="9144000" cy="6858000" type="screen4x3"/>
   <p:notesSz cx="6858000" cy="9144000"/>
   <p:defaultTextStyle>
     <a:defPPr>
@@ -3093,7 +3094,7 @@
     <p:bg>
       <p:bgPr>
         <a:solidFill>
-          <a:srgbClr val="FAFAF8"/>
+          <a:srgbClr val="FFFFFF"/>
         </a:solidFill>
         <a:effectLst/>
       </p:bgPr>
@@ -3113,8 +3114,8 @@
         </p:nvSpPr>
         <p:spPr>
           <a:xfrm>
-            <a:off x="502920" y="320040"/>
-            <a:ext cx="10789920" cy="320040"/>
+            <a:off x="731520" y="1325880"/>
+            <a:ext cx="7680960" cy="1097280"/>
           </a:xfrm>
           <a:prstGeom prst="rect">
             <a:avLst/>
@@ -3127,15 +3128,15 @@
           </a:bodyPr>
           <a:lstStyle/>
           <a:p>
-            <a:pPr>
-              <a:defRPr sz="1000" b="1">
-                <a:solidFill>
-                  <a:srgbClr val="366092"/>
-                </a:solidFill>
-              </a:defRPr>
-            </a:pPr>
-            <a:r>
-              <a:t>RESEARCH QUESTION</a:t>
+            <a:pPr algn="ctr">
+              <a:defRPr sz="2400" b="1">
+                <a:solidFill>
+                  <a:srgbClr val="004D99"/>
+                </a:solidFill>
+              </a:defRPr>
+            </a:pPr>
+            <a:r>
+              <a:t>LSTM vs Transformer Encoder for AG News Text Classification</a:t>
             </a:r>
           </a:p>
         </p:txBody>
@@ -3148,8 +3149,8 @@
         </p:nvSpPr>
         <p:spPr>
           <a:xfrm>
-            <a:off x="502920" y="658368"/>
-            <a:ext cx="10789920" cy="731520"/>
+            <a:off x="1097280" y="2971800"/>
+            <a:ext cx="6949440" cy="1280160"/>
           </a:xfrm>
           <a:prstGeom prst="rect">
             <a:avLst/>
@@ -3162,15 +3163,193 @@
           </a:bodyPr>
           <a:lstStyle/>
           <a:p>
-            <a:pPr>
-              <a:defRPr sz="2800" b="1">
+            <a:pPr algn="ctr">
+              <a:defRPr sz="1200" b="0"/>
+            </a:pPr>
+            <a:r>
+              <a:t>Course: Introduction to Deep Learning</a:t>
+            </a:r>
+          </a:p>
+          <a:p>
+            <a:pPr algn="ctr">
+              <a:defRPr sz="1200" b="0"/>
+            </a:pPr>
+            <a:r>
+              <a:t>AG News Classification Term Project</a:t>
+            </a:r>
+          </a:p>
+          <a:p>
+            <a:pPr algn="ctr">
+              <a:defRPr sz="1100" b="1"/>
+            </a:pPr>
+            <a:r>
+              <a:t>Muhammad Abdullah Hassan Malik</a:t>
+            </a:r>
+          </a:p>
+        </p:txBody>
+      </p:sp>
+      <p:sp>
+        <p:nvSpPr>
+          <p:cNvPr id="4" name="TextBox 3"/>
+          <p:cNvSpPr txBox="1"/>
+          <p:nvPr/>
+        </p:nvSpPr>
+        <p:spPr>
+          <a:xfrm>
+            <a:off x="109728" y="6565392"/>
+            <a:ext cx="3200400" cy="146304"/>
+          </a:xfrm>
+          <a:prstGeom prst="rect">
+            <a:avLst/>
+          </a:prstGeom>
+          <a:noFill/>
+        </p:spPr>
+        <p:txBody>
+          <a:bodyPr wrap="none">
+            <a:spAutoFit/>
+          </a:bodyPr>
+          <a:lstStyle/>
+          <a:p>
+            <a:pPr>
+              <a:defRPr sz="550">
+                <a:solidFill>
+                  <a:srgbClr val="1F4E79"/>
+                </a:solidFill>
+              </a:defRPr>
+            </a:pPr>
+            <a:r>
+              <a:t>Advanced Battery Manufacturing Systems</a:t>
+            </a:r>
+          </a:p>
+        </p:txBody>
+      </p:sp>
+      <p:sp>
+        <p:nvSpPr>
+          <p:cNvPr id="5" name="TextBox 4"/>
+          <p:cNvSpPr txBox="1"/>
+          <p:nvPr/>
+        </p:nvSpPr>
+        <p:spPr>
+          <a:xfrm>
+            <a:off x="8412480" y="6565392"/>
+            <a:ext cx="502920" cy="146304"/>
+          </a:xfrm>
+          <a:prstGeom prst="rect">
+            <a:avLst/>
+          </a:prstGeom>
+          <a:noFill/>
+        </p:spPr>
+        <p:txBody>
+          <a:bodyPr wrap="none">
+            <a:spAutoFit/>
+          </a:bodyPr>
+          <a:lstStyle/>
+          <a:p>
+            <a:pPr algn="r">
+              <a:defRPr sz="550">
+                <a:solidFill>
+                  <a:srgbClr val="787878"/>
+                </a:solidFill>
+              </a:defRPr>
+            </a:pPr>
+            <a:r>
+              <a:t>1 of 11</a:t>
+            </a:r>
+          </a:p>
+        </p:txBody>
+      </p:sp>
+    </p:spTree>
+  </p:cSld>
+  <p:clrMapOvr>
+    <a:masterClrMapping/>
+  </p:clrMapOvr>
+</p:sld>
+</file>
+
+<file path=ppt/slides/slide10.xml><?xml version="1.0" encoding="utf-8"?>
+<p:sld xmlns:a="http://schemas.openxmlformats.org/drawingml/2006/main" xmlns:p="http://schemas.openxmlformats.org/presentationml/2006/main" xmlns:r="http://schemas.openxmlformats.org/officeDocument/2006/relationships">
+  <p:cSld>
+    <p:bg>
+      <p:bgPr>
+        <a:solidFill>
+          <a:srgbClr val="FFFFFF"/>
+        </a:solidFill>
+        <a:effectLst/>
+      </p:bgPr>
+    </p:bg>
+    <p:spTree>
+      <p:nvGrpSpPr>
+        <p:cNvPr id="1" name=""/>
+        <p:cNvGrpSpPr/>
+        <p:nvPr/>
+      </p:nvGrpSpPr>
+      <p:grpSpPr/>
+      <p:sp>
+        <p:nvSpPr>
+          <p:cNvPr id="2" name="TextBox 1"/>
+          <p:cNvSpPr txBox="1"/>
+          <p:nvPr/>
+        </p:nvSpPr>
+        <p:spPr>
+          <a:xfrm>
+            <a:off x="73152" y="109728"/>
+            <a:ext cx="228600" cy="201168"/>
+          </a:xfrm>
+          <a:prstGeom prst="rect">
+            <a:avLst/>
+          </a:prstGeom>
+          <a:noFill/>
+        </p:spPr>
+        <p:txBody>
+          <a:bodyPr wrap="none">
+            <a:spAutoFit/>
+          </a:bodyPr>
+          <a:lstStyle/>
+          <a:p>
+            <a:pPr>
+              <a:defRPr sz="1300" b="1">
+                <a:solidFill>
+                  <a:srgbClr val="1F4E79"/>
+                </a:solidFill>
+              </a:defRPr>
+            </a:pPr>
+            <a:r>
+              <a:t>10</a:t>
+            </a:r>
+          </a:p>
+        </p:txBody>
+      </p:sp>
+      <p:sp>
+        <p:nvSpPr>
+          <p:cNvPr id="3" name="TextBox 2"/>
+          <p:cNvSpPr txBox="1"/>
+          <p:nvPr/>
+        </p:nvSpPr>
+        <p:spPr>
+          <a:xfrm>
+            <a:off x="256032" y="146304"/>
+            <a:ext cx="8458200" cy="384048"/>
+          </a:xfrm>
+          <a:prstGeom prst="rect">
+            <a:avLst/>
+          </a:prstGeom>
+          <a:noFill/>
+        </p:spPr>
+        <p:txBody>
+          <a:bodyPr wrap="square">
+            <a:spAutoFit/>
+          </a:bodyPr>
+          <a:lstStyle/>
+          <a:p>
+            <a:pPr>
+              <a:defRPr sz="1500" b="1">
                 <a:solidFill>
                   <a:srgbClr val="0B2545"/>
                 </a:solidFill>
               </a:defRPr>
             </a:pPr>
             <a:r>
-              <a:t>One controlled AG News pipeline compares recurrent modeling and self-attention.</a:t>
+              <a:t>LSTM is more stable with less data; Transformer benefits from the full dataset.</a:t>
             </a:r>
           </a:p>
         </p:txBody>
@@ -3183,18 +3362,18 @@
         </p:nvSpPr>
         <p:spPr>
           <a:xfrm>
-            <a:off x="685800" y="1874519"/>
-            <a:ext cx="2240280" cy="1097280"/>
+            <a:off x="256032" y="530352"/>
+            <a:ext cx="8458200" cy="18288"/>
           </a:xfrm>
           <a:prstGeom prst="rect">
             <a:avLst/>
           </a:prstGeom>
           <a:solidFill>
-            <a:srgbClr val="F2F4F7"/>
+            <a:srgbClr val="1F4E79"/>
           </a:solidFill>
           <a:ln>
             <a:solidFill>
-              <a:srgbClr val="D2D8E0"/>
+              <a:srgbClr val="1F4E79"/>
             </a:solidFill>
           </a:ln>
         </p:spPr>
@@ -3216,51 +3395,279 @@
           <a:bodyPr rtlCol="0" anchor="ctr"/>
           <a:lstStyle/>
           <a:p>
-            <a:pPr algn="ctr">
-              <a:defRPr sz="2400" b="1">
-                <a:solidFill>
-                  <a:srgbClr val="2E74B5"/>
-                </a:solidFill>
-              </a:defRPr>
-            </a:pPr>
-            <a:r>
-              <a:t>91.25%</a:t>
-            </a:r>
-          </a:p>
-          <a:p>
-            <a:pPr algn="ctr">
-              <a:defRPr sz="1100">
-                <a:solidFill>
-                  <a:srgbClr val="464646"/>
-                </a:solidFill>
-              </a:defRPr>
-            </a:pPr>
-            <a:r>
-              <a:t>best test accuracy</a:t>
-            </a:r>
-          </a:p>
-        </p:txBody>
-      </p:sp>
-      <p:sp>
-        <p:nvSpPr>
-          <p:cNvPr id="5" name="Rectangle 4"/>
+            <a:pPr algn="ctr"/>
+          </a:p>
+        </p:txBody>
+      </p:sp>
+      <p:sp>
+        <p:nvSpPr>
+          <p:cNvPr id="5" name="TextBox 4"/>
+          <p:cNvSpPr txBox="1"/>
+          <p:nvPr/>
+        </p:nvSpPr>
+        <p:spPr>
+          <a:xfrm>
+            <a:off x="685800" y="960120"/>
+            <a:ext cx="7772400" cy="5212080"/>
+          </a:xfrm>
+          <a:prstGeom prst="rect">
+            <a:avLst/>
+          </a:prstGeom>
+          <a:noFill/>
+        </p:spPr>
+        <p:txBody>
+          <a:bodyPr wrap="square">
+            <a:spAutoFit/>
+          </a:bodyPr>
+          <a:lstStyle/>
+          <a:p>
+            <a:pPr>
+              <a:spcAft>
+                <a:spcPts val="500"/>
+              </a:spcAft>
+              <a:defRPr sz="1200">
+                <a:solidFill>
+                  <a:srgbClr val="232323"/>
+                </a:solidFill>
+              </a:defRPr>
+            </a:pPr>
+            <a:r>
+              <a:t>25% data: LSTM 0.8719 vs Transformer 0.8699 validation accuracy.</a:t>
+            </a:r>
+          </a:p>
+          <a:p>
+            <a:pPr>
+              <a:spcAft>
+                <a:spcPts val="500"/>
+              </a:spcAft>
+              <a:defRPr sz="1200">
+                <a:solidFill>
+                  <a:srgbClr val="232323"/>
+                </a:solidFill>
+              </a:defRPr>
+            </a:pPr>
+            <a:r>
+              <a:t>50% data: LSTM 0.8944 vs Transformer 0.8901.</a:t>
+            </a:r>
+          </a:p>
+          <a:p>
+            <a:pPr>
+              <a:spcAft>
+                <a:spcPts val="500"/>
+              </a:spcAft>
+              <a:defRPr sz="1200">
+                <a:solidFill>
+                  <a:srgbClr val="232323"/>
+                </a:solidFill>
+              </a:defRPr>
+            </a:pPr>
+            <a:r>
+              <a:t>100% data: Transformer 0.9146 vs LSTM 0.9089.</a:t>
+            </a:r>
+          </a:p>
+          <a:p>
+            <a:pPr>
+              <a:spcAft>
+                <a:spcPts val="500"/>
+              </a:spcAft>
+              <a:defRPr sz="1200">
+                <a:solidFill>
+                  <a:srgbClr val="232323"/>
+                </a:solidFill>
+              </a:defRPr>
+            </a:pPr>
+            <a:r>
+              <a:t>The result supports the data-efficiency hypothesis.</a:t>
+            </a:r>
+          </a:p>
+        </p:txBody>
+      </p:sp>
+      <p:sp>
+        <p:nvSpPr>
+          <p:cNvPr id="6" name="TextBox 5"/>
+          <p:cNvSpPr txBox="1"/>
+          <p:nvPr/>
+        </p:nvSpPr>
+        <p:spPr>
+          <a:xfrm>
+            <a:off x="109728" y="6565392"/>
+            <a:ext cx="3200400" cy="146304"/>
+          </a:xfrm>
+          <a:prstGeom prst="rect">
+            <a:avLst/>
+          </a:prstGeom>
+          <a:noFill/>
+        </p:spPr>
+        <p:txBody>
+          <a:bodyPr wrap="none">
+            <a:spAutoFit/>
+          </a:bodyPr>
+          <a:lstStyle/>
+          <a:p>
+            <a:pPr>
+              <a:defRPr sz="550">
+                <a:solidFill>
+                  <a:srgbClr val="1F4E79"/>
+                </a:solidFill>
+              </a:defRPr>
+            </a:pPr>
+            <a:r>
+              <a:t>Advanced Battery Manufacturing Systems</a:t>
+            </a:r>
+          </a:p>
+        </p:txBody>
+      </p:sp>
+      <p:sp>
+        <p:nvSpPr>
+          <p:cNvPr id="7" name="TextBox 6"/>
+          <p:cNvSpPr txBox="1"/>
+          <p:nvPr/>
+        </p:nvSpPr>
+        <p:spPr>
+          <a:xfrm>
+            <a:off x="8412480" y="6565392"/>
+            <a:ext cx="502920" cy="146304"/>
+          </a:xfrm>
+          <a:prstGeom prst="rect">
+            <a:avLst/>
+          </a:prstGeom>
+          <a:noFill/>
+        </p:spPr>
+        <p:txBody>
+          <a:bodyPr wrap="none">
+            <a:spAutoFit/>
+          </a:bodyPr>
+          <a:lstStyle/>
+          <a:p>
+            <a:pPr algn="r">
+              <a:defRPr sz="550">
+                <a:solidFill>
+                  <a:srgbClr val="787878"/>
+                </a:solidFill>
+              </a:defRPr>
+            </a:pPr>
+            <a:r>
+              <a:t>10 of 11</a:t>
+            </a:r>
+          </a:p>
+        </p:txBody>
+      </p:sp>
+    </p:spTree>
+  </p:cSld>
+  <p:clrMapOvr>
+    <a:masterClrMapping/>
+  </p:clrMapOvr>
+</p:sld>
+</file>
+
+<file path=ppt/slides/slide11.xml><?xml version="1.0" encoding="utf-8"?>
+<p:sld xmlns:a="http://schemas.openxmlformats.org/drawingml/2006/main" xmlns:p="http://schemas.openxmlformats.org/presentationml/2006/main" xmlns:r="http://schemas.openxmlformats.org/officeDocument/2006/relationships">
+  <p:cSld>
+    <p:bg>
+      <p:bgPr>
+        <a:solidFill>
+          <a:srgbClr val="FFFFFF"/>
+        </a:solidFill>
+        <a:effectLst/>
+      </p:bgPr>
+    </p:bg>
+    <p:spTree>
+      <p:nvGrpSpPr>
+        <p:cNvPr id="1" name=""/>
+        <p:cNvGrpSpPr/>
+        <p:nvPr/>
+      </p:nvGrpSpPr>
+      <p:grpSpPr/>
+      <p:sp>
+        <p:nvSpPr>
+          <p:cNvPr id="2" name="TextBox 1"/>
+          <p:cNvSpPr txBox="1"/>
+          <p:nvPr/>
+        </p:nvSpPr>
+        <p:spPr>
+          <a:xfrm>
+            <a:off x="73152" y="109728"/>
+            <a:ext cx="228600" cy="201168"/>
+          </a:xfrm>
+          <a:prstGeom prst="rect">
+            <a:avLst/>
+          </a:prstGeom>
+          <a:noFill/>
+        </p:spPr>
+        <p:txBody>
+          <a:bodyPr wrap="none">
+            <a:spAutoFit/>
+          </a:bodyPr>
+          <a:lstStyle/>
+          <a:p>
+            <a:pPr>
+              <a:defRPr sz="1300" b="1">
+                <a:solidFill>
+                  <a:srgbClr val="1F4E79"/>
+                </a:solidFill>
+              </a:defRPr>
+            </a:pPr>
+            <a:r>
+              <a:t>11</a:t>
+            </a:r>
+          </a:p>
+        </p:txBody>
+      </p:sp>
+      <p:sp>
+        <p:nvSpPr>
+          <p:cNvPr id="3" name="TextBox 2"/>
+          <p:cNvSpPr txBox="1"/>
+          <p:nvPr/>
+        </p:nvSpPr>
+        <p:spPr>
+          <a:xfrm>
+            <a:off x="256032" y="146304"/>
+            <a:ext cx="8458200" cy="384048"/>
+          </a:xfrm>
+          <a:prstGeom prst="rect">
+            <a:avLst/>
+          </a:prstGeom>
+          <a:noFill/>
+        </p:spPr>
+        <p:txBody>
+          <a:bodyPr wrap="square">
+            <a:spAutoFit/>
+          </a:bodyPr>
+          <a:lstStyle/>
+          <a:p>
+            <a:pPr>
+              <a:defRPr sz="1500" b="1">
+                <a:solidFill>
+                  <a:srgbClr val="0B2545"/>
+                </a:solidFill>
+              </a:defRPr>
+            </a:pPr>
+            <a:r>
+              <a:t>Architecture differences appear most clearly in data efficiency and failure patterns.</a:t>
+            </a:r>
+          </a:p>
+        </p:txBody>
+      </p:sp>
+      <p:sp>
+        <p:nvSpPr>
+          <p:cNvPr id="4" name="Rectangle 3"/>
           <p:cNvSpPr/>
           <p:nvPr/>
         </p:nvSpPr>
         <p:spPr>
           <a:xfrm>
-            <a:off x="3154680" y="1874519"/>
-            <a:ext cx="2240280" cy="1097280"/>
+            <a:off x="256032" y="530352"/>
+            <a:ext cx="8458200" cy="18288"/>
           </a:xfrm>
           <a:prstGeom prst="rect">
             <a:avLst/>
           </a:prstGeom>
           <a:solidFill>
-            <a:srgbClr val="F2F4F7"/>
+            <a:srgbClr val="1F4E79"/>
           </a:solidFill>
           <a:ln>
             <a:solidFill>
-              <a:srgbClr val="D2D8E0"/>
+              <a:srgbClr val="1F4E79"/>
             </a:solidFill>
           </a:ln>
         </p:spPr>
@@ -3282,51 +3689,279 @@
           <a:bodyPr rtlCol="0" anchor="ctr"/>
           <a:lstStyle/>
           <a:p>
-            <a:pPr algn="ctr">
-              <a:defRPr sz="2400" b="1">
-                <a:solidFill>
-                  <a:srgbClr val="595959"/>
-                </a:solidFill>
-              </a:defRPr>
-            </a:pPr>
-            <a:r>
-              <a:t>6</a:t>
-            </a:r>
-          </a:p>
-          <a:p>
-            <a:pPr algn="ctr">
-              <a:defRPr sz="1100">
-                <a:solidFill>
-                  <a:srgbClr val="464646"/>
-                </a:solidFill>
-              </a:defRPr>
-            </a:pPr>
-            <a:r>
-              <a:t>training epochs</a:t>
-            </a:r>
-          </a:p>
-        </p:txBody>
-      </p:sp>
-      <p:sp>
-        <p:nvSpPr>
-          <p:cNvPr id="6" name="Rectangle 5"/>
+            <a:pPr algn="ctr"/>
+          </a:p>
+        </p:txBody>
+      </p:sp>
+      <p:sp>
+        <p:nvSpPr>
+          <p:cNvPr id="5" name="TextBox 4"/>
+          <p:cNvSpPr txBox="1"/>
+          <p:nvPr/>
+        </p:nvSpPr>
+        <p:spPr>
+          <a:xfrm>
+            <a:off x="685800" y="960120"/>
+            <a:ext cx="7772400" cy="5212080"/>
+          </a:xfrm>
+          <a:prstGeom prst="rect">
+            <a:avLst/>
+          </a:prstGeom>
+          <a:noFill/>
+        </p:spPr>
+        <p:txBody>
+          <a:bodyPr wrap="square">
+            <a:spAutoFit/>
+          </a:bodyPr>
+          <a:lstStyle/>
+          <a:p>
+            <a:pPr>
+              <a:spcAft>
+                <a:spcPts val="500"/>
+              </a:spcAft>
+              <a:defRPr sz="1200">
+                <a:solidFill>
+                  <a:srgbClr val="232323"/>
+                </a:solidFill>
+              </a:defRPr>
+            </a:pPr>
+            <a:r>
+              <a:t>Transformer Encoder slightly wins the final test comparison.</a:t>
+            </a:r>
+          </a:p>
+          <a:p>
+            <a:pPr>
+              <a:spcAft>
+                <a:spcPts val="500"/>
+              </a:spcAft>
+              <a:defRPr sz="1200">
+                <a:solidFill>
+                  <a:srgbClr val="232323"/>
+                </a:solidFill>
+              </a:defRPr>
+            </a:pPr>
+            <a:r>
+              <a:t>LSTM performs better in limited-data settings.</a:t>
+            </a:r>
+          </a:p>
+          <a:p>
+            <a:pPr>
+              <a:spcAft>
+                <a:spcPts val="500"/>
+              </a:spcAft>
+              <a:defRPr sz="1200">
+                <a:solidFill>
+                  <a:srgbClr val="232323"/>
+                </a:solidFill>
+              </a:defRPr>
+            </a:pPr>
+            <a:r>
+              <a:t>Longer 256-token inputs did not improve validation metrics.</a:t>
+            </a:r>
+          </a:p>
+          <a:p>
+            <a:pPr>
+              <a:spcAft>
+                <a:spcPts val="500"/>
+              </a:spcAft>
+              <a:defRPr sz="1200">
+                <a:solidFill>
+                  <a:srgbClr val="232323"/>
+                </a:solidFill>
+              </a:defRPr>
+            </a:pPr>
+            <a:r>
+              <a:t>Future work: early stopping, regularization, and class-level error reduction.</a:t>
+            </a:r>
+          </a:p>
+        </p:txBody>
+      </p:sp>
+      <p:sp>
+        <p:nvSpPr>
+          <p:cNvPr id="6" name="TextBox 5"/>
+          <p:cNvSpPr txBox="1"/>
+          <p:nvPr/>
+        </p:nvSpPr>
+        <p:spPr>
+          <a:xfrm>
+            <a:off x="109728" y="6565392"/>
+            <a:ext cx="3200400" cy="146304"/>
+          </a:xfrm>
+          <a:prstGeom prst="rect">
+            <a:avLst/>
+          </a:prstGeom>
+          <a:noFill/>
+        </p:spPr>
+        <p:txBody>
+          <a:bodyPr wrap="none">
+            <a:spAutoFit/>
+          </a:bodyPr>
+          <a:lstStyle/>
+          <a:p>
+            <a:pPr>
+              <a:defRPr sz="550">
+                <a:solidFill>
+                  <a:srgbClr val="1F4E79"/>
+                </a:solidFill>
+              </a:defRPr>
+            </a:pPr>
+            <a:r>
+              <a:t>Advanced Battery Manufacturing Systems</a:t>
+            </a:r>
+          </a:p>
+        </p:txBody>
+      </p:sp>
+      <p:sp>
+        <p:nvSpPr>
+          <p:cNvPr id="7" name="TextBox 6"/>
+          <p:cNvSpPr txBox="1"/>
+          <p:nvPr/>
+        </p:nvSpPr>
+        <p:spPr>
+          <a:xfrm>
+            <a:off x="8412480" y="6565392"/>
+            <a:ext cx="502920" cy="146304"/>
+          </a:xfrm>
+          <a:prstGeom prst="rect">
+            <a:avLst/>
+          </a:prstGeom>
+          <a:noFill/>
+        </p:spPr>
+        <p:txBody>
+          <a:bodyPr wrap="none">
+            <a:spAutoFit/>
+          </a:bodyPr>
+          <a:lstStyle/>
+          <a:p>
+            <a:pPr algn="r">
+              <a:defRPr sz="550">
+                <a:solidFill>
+                  <a:srgbClr val="787878"/>
+                </a:solidFill>
+              </a:defRPr>
+            </a:pPr>
+            <a:r>
+              <a:t>11 of 11</a:t>
+            </a:r>
+          </a:p>
+        </p:txBody>
+      </p:sp>
+    </p:spTree>
+  </p:cSld>
+  <p:clrMapOvr>
+    <a:masterClrMapping/>
+  </p:clrMapOvr>
+</p:sld>
+</file>
+
+<file path=ppt/slides/slide2.xml><?xml version="1.0" encoding="utf-8"?>
+<p:sld xmlns:a="http://schemas.openxmlformats.org/drawingml/2006/main" xmlns:p="http://schemas.openxmlformats.org/presentationml/2006/main" xmlns:r="http://schemas.openxmlformats.org/officeDocument/2006/relationships">
+  <p:cSld>
+    <p:bg>
+      <p:bgPr>
+        <a:solidFill>
+          <a:srgbClr val="FFFFFF"/>
+        </a:solidFill>
+        <a:effectLst/>
+      </p:bgPr>
+    </p:bg>
+    <p:spTree>
+      <p:nvGrpSpPr>
+        <p:cNvPr id="1" name=""/>
+        <p:cNvGrpSpPr/>
+        <p:nvPr/>
+      </p:nvGrpSpPr>
+      <p:grpSpPr/>
+      <p:sp>
+        <p:nvSpPr>
+          <p:cNvPr id="2" name="TextBox 1"/>
+          <p:cNvSpPr txBox="1"/>
+          <p:nvPr/>
+        </p:nvSpPr>
+        <p:spPr>
+          <a:xfrm>
+            <a:off x="73152" y="109728"/>
+            <a:ext cx="228600" cy="201168"/>
+          </a:xfrm>
+          <a:prstGeom prst="rect">
+            <a:avLst/>
+          </a:prstGeom>
+          <a:noFill/>
+        </p:spPr>
+        <p:txBody>
+          <a:bodyPr wrap="none">
+            <a:spAutoFit/>
+          </a:bodyPr>
+          <a:lstStyle/>
+          <a:p>
+            <a:pPr>
+              <a:defRPr sz="1300" b="1">
+                <a:solidFill>
+                  <a:srgbClr val="1F4E79"/>
+                </a:solidFill>
+              </a:defRPr>
+            </a:pPr>
+            <a:r>
+              <a:t>2</a:t>
+            </a:r>
+          </a:p>
+        </p:txBody>
+      </p:sp>
+      <p:sp>
+        <p:nvSpPr>
+          <p:cNvPr id="3" name="TextBox 2"/>
+          <p:cNvSpPr txBox="1"/>
+          <p:nvPr/>
+        </p:nvSpPr>
+        <p:spPr>
+          <a:xfrm>
+            <a:off x="256032" y="146304"/>
+            <a:ext cx="8458200" cy="384048"/>
+          </a:xfrm>
+          <a:prstGeom prst="rect">
+            <a:avLst/>
+          </a:prstGeom>
+          <a:noFill/>
+        </p:spPr>
+        <p:txBody>
+          <a:bodyPr wrap="square">
+            <a:spAutoFit/>
+          </a:bodyPr>
+          <a:lstStyle/>
+          <a:p>
+            <a:pPr>
+              <a:defRPr sz="1700" b="1">
+                <a:solidFill>
+                  <a:srgbClr val="0B2545"/>
+                </a:solidFill>
+              </a:defRPr>
+            </a:pPr>
+            <a:r>
+              <a:t>Table of Contents</a:t>
+            </a:r>
+          </a:p>
+        </p:txBody>
+      </p:sp>
+      <p:sp>
+        <p:nvSpPr>
+          <p:cNvPr id="4" name="Rectangle 3"/>
           <p:cNvSpPr/>
           <p:nvPr/>
         </p:nvSpPr>
         <p:spPr>
           <a:xfrm>
-            <a:off x="5623560" y="1874519"/>
-            <a:ext cx="2240280" cy="1097280"/>
+            <a:off x="256032" y="530352"/>
+            <a:ext cx="8458200" cy="18288"/>
           </a:xfrm>
           <a:prstGeom prst="rect">
             <a:avLst/>
           </a:prstGeom>
           <a:solidFill>
-            <a:srgbClr val="F2F4F7"/>
+            <a:srgbClr val="1F4E79"/>
           </a:solidFill>
           <a:ln>
             <a:solidFill>
-              <a:srgbClr val="D2D8E0"/>
+              <a:srgbClr val="1F4E79"/>
             </a:solidFill>
           </a:ln>
         </p:spPr>
@@ -3348,41 +3983,20 @@
           <a:bodyPr rtlCol="0" anchor="ctr"/>
           <a:lstStyle/>
           <a:p>
-            <a:pPr algn="ctr">
-              <a:defRPr sz="2400" b="1">
-                <a:solidFill>
-                  <a:srgbClr val="1F4D78"/>
-                </a:solidFill>
-              </a:defRPr>
-            </a:pPr>
-            <a:r>
-              <a:t>3</a:t>
-            </a:r>
-          </a:p>
-          <a:p>
-            <a:pPr algn="ctr">
-              <a:defRPr sz="1100">
-                <a:solidFill>
-                  <a:srgbClr val="464646"/>
-                </a:solidFill>
-              </a:defRPr>
-            </a:pPr>
-            <a:r>
-              <a:t>ablation sizes</a:t>
-            </a:r>
-          </a:p>
-        </p:txBody>
-      </p:sp>
-      <p:sp>
-        <p:nvSpPr>
-          <p:cNvPr id="7" name="TextBox 6"/>
+            <a:pPr algn="ctr"/>
+          </a:p>
+        </p:txBody>
+      </p:sp>
+      <p:sp>
+        <p:nvSpPr>
+          <p:cNvPr id="5" name="TextBox 4"/>
           <p:cNvSpPr txBox="1"/>
           <p:nvPr/>
         </p:nvSpPr>
         <p:spPr>
           <a:xfrm>
-            <a:off x="777240" y="3337560"/>
-            <a:ext cx="10058400" cy="1828800"/>
+            <a:off x="685800" y="960120"/>
+            <a:ext cx="7589520" cy="4389120"/>
           </a:xfrm>
           <a:prstGeom prst="rect">
             <a:avLst/>
@@ -3397,60 +4011,120 @@
           <a:p>
             <a:pPr>
               <a:spcAft>
-                <a:spcPts val="800"/>
+                <a:spcPts val="500"/>
               </a:spcAft>
-              <a:defRPr sz="1800">
+              <a:defRPr sz="1300">
                 <a:solidFill>
                   <a:srgbClr val="232323"/>
                 </a:solidFill>
               </a:defRPr>
             </a:pPr>
             <a:r>
-              <a:t>Compare LSTM and Transformer Encoder classifiers trained from scratch.</a:t>
+              <a:t>Introduction and Motivation</a:t>
             </a:r>
           </a:p>
           <a:p>
             <a:pPr>
               <a:spcAft>
-                <a:spcPts val="800"/>
+                <a:spcPts val="500"/>
               </a:spcAft>
-              <a:defRPr sz="1800">
+              <a:defRPr sz="1300">
                 <a:solidFill>
                   <a:srgbClr val="232323"/>
                 </a:solidFill>
               </a:defRPr>
             </a:pPr>
             <a:r>
-              <a:t>Analyze accuracy, macro F1, convergence, ablation behavior, and failure cases.</a:t>
+              <a:t>Dataset and Preprocessing</a:t>
             </a:r>
           </a:p>
           <a:p>
             <a:pPr>
               <a:spcAft>
-                <a:spcPts val="800"/>
+                <a:spcPts val="500"/>
               </a:spcAft>
-              <a:defRPr sz="1800">
+              <a:defRPr sz="1300">
                 <a:solidFill>
                   <a:srgbClr val="232323"/>
                 </a:solidFill>
               </a:defRPr>
             </a:pPr>
             <a:r>
-              <a:t>No pretrained language models or pretrained embeddings.</a:t>
-            </a:r>
-          </a:p>
-        </p:txBody>
-      </p:sp>
-      <p:sp>
-        <p:nvSpPr>
-          <p:cNvPr id="8" name="TextBox 7"/>
+              <a:t>Model Development</a:t>
+            </a:r>
+          </a:p>
+          <a:p>
+            <a:pPr>
+              <a:spcAft>
+                <a:spcPts val="500"/>
+              </a:spcAft>
+              <a:defRPr sz="1300">
+                <a:solidFill>
+                  <a:srgbClr val="232323"/>
+                </a:solidFill>
+              </a:defRPr>
+            </a:pPr>
+            <a:r>
+              <a:t>Main Comparison Results</a:t>
+            </a:r>
+          </a:p>
+          <a:p>
+            <a:pPr>
+              <a:spcAft>
+                <a:spcPts val="500"/>
+              </a:spcAft>
+              <a:defRPr sz="1300">
+                <a:solidFill>
+                  <a:srgbClr val="232323"/>
+                </a:solidFill>
+              </a:defRPr>
+            </a:pPr>
+            <a:r>
+              <a:t>Ablation Study</a:t>
+            </a:r>
+          </a:p>
+          <a:p>
+            <a:pPr>
+              <a:spcAft>
+                <a:spcPts val="500"/>
+              </a:spcAft>
+              <a:defRPr sz="1300">
+                <a:solidFill>
+                  <a:srgbClr val="232323"/>
+                </a:solidFill>
+              </a:defRPr>
+            </a:pPr>
+            <a:r>
+              <a:t>Failure Analysis</a:t>
+            </a:r>
+          </a:p>
+          <a:p>
+            <a:pPr>
+              <a:spcAft>
+                <a:spcPts val="500"/>
+              </a:spcAft>
+              <a:defRPr sz="1300">
+                <a:solidFill>
+                  <a:srgbClr val="232323"/>
+                </a:solidFill>
+              </a:defRPr>
+            </a:pPr>
+            <a:r>
+              <a:t>Conclusion and Future Work</a:t>
+            </a:r>
+          </a:p>
+        </p:txBody>
+      </p:sp>
+      <p:sp>
+        <p:nvSpPr>
+          <p:cNvPr id="6" name="TextBox 5"/>
           <p:cNvSpPr txBox="1"/>
           <p:nvPr/>
         </p:nvSpPr>
         <p:spPr>
           <a:xfrm>
-            <a:off x="10881360" y="6355080"/>
-            <a:ext cx="640080" cy="182880"/>
+            <a:off x="109728" y="6565392"/>
+            <a:ext cx="3200400" cy="146304"/>
           </a:xfrm>
           <a:prstGeom prst="rect">
             <a:avLst/>
@@ -3463,55 +4137,29 @@
           </a:bodyPr>
           <a:lstStyle/>
           <a:p>
-            <a:pPr algn="r">
-              <a:defRPr sz="800">
-                <a:solidFill>
-                  <a:srgbClr val="787878"/>
-                </a:solidFill>
-              </a:defRPr>
-            </a:pPr>
-            <a:r>
-              <a:t>1</a:t>
-            </a:r>
-          </a:p>
-        </p:txBody>
-      </p:sp>
-    </p:spTree>
-  </p:cSld>
-  <p:clrMapOvr>
-    <a:masterClrMapping/>
-  </p:clrMapOvr>
-</p:sld>
-</file>
-
-<file path=ppt/slides/slide10.xml><?xml version="1.0" encoding="utf-8"?>
-<p:sld xmlns:a="http://schemas.openxmlformats.org/drawingml/2006/main" xmlns:p="http://schemas.openxmlformats.org/presentationml/2006/main" xmlns:r="http://schemas.openxmlformats.org/officeDocument/2006/relationships">
-  <p:cSld>
-    <p:bg>
-      <p:bgPr>
-        <a:solidFill>
-          <a:srgbClr val="FAFAF8"/>
-        </a:solidFill>
-        <a:effectLst/>
-      </p:bgPr>
-    </p:bg>
-    <p:spTree>
-      <p:nvGrpSpPr>
-        <p:cNvPr id="1" name=""/>
-        <p:cNvGrpSpPr/>
-        <p:nvPr/>
-      </p:nvGrpSpPr>
-      <p:grpSpPr/>
-      <p:sp>
-        <p:nvSpPr>
-          <p:cNvPr id="2" name="TextBox 1"/>
+            <a:pPr>
+              <a:defRPr sz="550">
+                <a:solidFill>
+                  <a:srgbClr val="1F4E79"/>
+                </a:solidFill>
+              </a:defRPr>
+            </a:pPr>
+            <a:r>
+              <a:t>Advanced Battery Manufacturing Systems</a:t>
+            </a:r>
+          </a:p>
+        </p:txBody>
+      </p:sp>
+      <p:sp>
+        <p:nvSpPr>
+          <p:cNvPr id="7" name="TextBox 6"/>
           <p:cNvSpPr txBox="1"/>
           <p:nvPr/>
         </p:nvSpPr>
         <p:spPr>
           <a:xfrm>
-            <a:off x="502920" y="320040"/>
-            <a:ext cx="10789920" cy="320040"/>
+            <a:off x="8412480" y="6565392"/>
+            <a:ext cx="502920" cy="146304"/>
           </a:xfrm>
           <a:prstGeom prst="rect">
             <a:avLst/>
@@ -3524,352 +4172,15 @@
           </a:bodyPr>
           <a:lstStyle/>
           <a:p>
-            <a:pPr>
-              <a:defRPr sz="1000" b="1">
-                <a:solidFill>
-                  <a:srgbClr val="366092"/>
-                </a:solidFill>
-              </a:defRPr>
-            </a:pPr>
-            <a:r>
-              <a:t>CONCLUSION</a:t>
-            </a:r>
-          </a:p>
-        </p:txBody>
-      </p:sp>
-      <p:sp>
-        <p:nvSpPr>
-          <p:cNvPr id="3" name="TextBox 2"/>
-          <p:cNvSpPr txBox="1"/>
-          <p:nvPr/>
-        </p:nvSpPr>
-        <p:spPr>
-          <a:xfrm>
-            <a:off x="502920" y="658368"/>
-            <a:ext cx="10789920" cy="731520"/>
-          </a:xfrm>
-          <a:prstGeom prst="rect">
-            <a:avLst/>
-          </a:prstGeom>
-          <a:noFill/>
-        </p:spPr>
-        <p:txBody>
-          <a:bodyPr wrap="none">
-            <a:spAutoFit/>
-          </a:bodyPr>
-          <a:lstStyle/>
-          <a:p>
-            <a:pPr>
-              <a:defRPr sz="2800" b="1">
-                <a:solidFill>
-                  <a:srgbClr val="0B2545"/>
-                </a:solidFill>
-              </a:defRPr>
-            </a:pPr>
-            <a:r>
-              <a:t>Architecture differences appear most clearly in data efficiency and failure patterns.</a:t>
-            </a:r>
-          </a:p>
-        </p:txBody>
-      </p:sp>
-      <p:sp>
-        <p:nvSpPr>
-          <p:cNvPr id="4" name="TextBox 3"/>
-          <p:cNvSpPr txBox="1"/>
-          <p:nvPr/>
-        </p:nvSpPr>
-        <p:spPr>
-          <a:xfrm>
-            <a:off x="822960" y="1691640"/>
-            <a:ext cx="10241280" cy="4389120"/>
-          </a:xfrm>
-          <a:prstGeom prst="rect">
-            <a:avLst/>
-          </a:prstGeom>
-          <a:noFill/>
-        </p:spPr>
-        <p:txBody>
-          <a:bodyPr wrap="square">
-            <a:spAutoFit/>
-          </a:bodyPr>
-          <a:lstStyle/>
-          <a:p>
-            <a:pPr>
-              <a:spcAft>
-                <a:spcPts val="800"/>
-              </a:spcAft>
-              <a:defRPr sz="2000">
-                <a:solidFill>
-                  <a:srgbClr val="232323"/>
-                </a:solidFill>
-              </a:defRPr>
-            </a:pPr>
-            <a:r>
-              <a:t>Transformer Encoder slightly wins the final test comparison.</a:t>
-            </a:r>
-          </a:p>
-          <a:p>
-            <a:pPr>
-              <a:spcAft>
-                <a:spcPts val="800"/>
-              </a:spcAft>
-              <a:defRPr sz="2000">
-                <a:solidFill>
-                  <a:srgbClr val="232323"/>
-                </a:solidFill>
-              </a:defRPr>
-            </a:pPr>
-            <a:r>
-              <a:t>LSTM performs better in limited-data settings.</a:t>
-            </a:r>
-          </a:p>
-          <a:p>
-            <a:pPr>
-              <a:spcAft>
-                <a:spcPts val="800"/>
-              </a:spcAft>
-              <a:defRPr sz="2000">
-                <a:solidFill>
-                  <a:srgbClr val="232323"/>
-                </a:solidFill>
-              </a:defRPr>
-            </a:pPr>
-            <a:r>
-              <a:t>Future work: early stopping, regularization, and class-level error reduction.</a:t>
-            </a:r>
-          </a:p>
-        </p:txBody>
-      </p:sp>
-      <p:sp>
-        <p:nvSpPr>
-          <p:cNvPr id="5" name="TextBox 4"/>
-          <p:cNvSpPr txBox="1"/>
-          <p:nvPr/>
-        </p:nvSpPr>
-        <p:spPr>
-          <a:xfrm>
-            <a:off x="10881360" y="6355080"/>
-            <a:ext cx="640080" cy="182880"/>
-          </a:xfrm>
-          <a:prstGeom prst="rect">
-            <a:avLst/>
-          </a:prstGeom>
-          <a:noFill/>
-        </p:spPr>
-        <p:txBody>
-          <a:bodyPr wrap="none">
-            <a:spAutoFit/>
-          </a:bodyPr>
-          <a:lstStyle/>
-          <a:p>
             <a:pPr algn="r">
-              <a:defRPr sz="800">
+              <a:defRPr sz="550">
                 <a:solidFill>
                   <a:srgbClr val="787878"/>
                 </a:solidFill>
               </a:defRPr>
             </a:pPr>
             <a:r>
-              <a:t>10</a:t>
-            </a:r>
-          </a:p>
-        </p:txBody>
-      </p:sp>
-    </p:spTree>
-  </p:cSld>
-  <p:clrMapOvr>
-    <a:masterClrMapping/>
-  </p:clrMapOvr>
-</p:sld>
-</file>
-
-<file path=ppt/slides/slide2.xml><?xml version="1.0" encoding="utf-8"?>
-<p:sld xmlns:a="http://schemas.openxmlformats.org/drawingml/2006/main" xmlns:p="http://schemas.openxmlformats.org/presentationml/2006/main" xmlns:r="http://schemas.openxmlformats.org/officeDocument/2006/relationships">
-  <p:cSld>
-    <p:bg>
-      <p:bgPr>
-        <a:solidFill>
-          <a:srgbClr val="FAFAF8"/>
-        </a:solidFill>
-        <a:effectLst/>
-      </p:bgPr>
-    </p:bg>
-    <p:spTree>
-      <p:nvGrpSpPr>
-        <p:cNvPr id="1" name=""/>
-        <p:cNvGrpSpPr/>
-        <p:nvPr/>
-      </p:nvGrpSpPr>
-      <p:grpSpPr/>
-      <p:sp>
-        <p:nvSpPr>
-          <p:cNvPr id="2" name="TextBox 1"/>
-          <p:cNvSpPr txBox="1"/>
-          <p:nvPr/>
-        </p:nvSpPr>
-        <p:spPr>
-          <a:xfrm>
-            <a:off x="502920" y="320040"/>
-            <a:ext cx="10789920" cy="320040"/>
-          </a:xfrm>
-          <a:prstGeom prst="rect">
-            <a:avLst/>
-          </a:prstGeom>
-          <a:noFill/>
-        </p:spPr>
-        <p:txBody>
-          <a:bodyPr wrap="none">
-            <a:spAutoFit/>
-          </a:bodyPr>
-          <a:lstStyle/>
-          <a:p>
-            <a:pPr>
-              <a:defRPr sz="1000" b="1">
-                <a:solidFill>
-                  <a:srgbClr val="366092"/>
-                </a:solidFill>
-              </a:defRPr>
-            </a:pPr>
-            <a:r>
-              <a:t>DATASET</a:t>
-            </a:r>
-          </a:p>
-        </p:txBody>
-      </p:sp>
-      <p:sp>
-        <p:nvSpPr>
-          <p:cNvPr id="3" name="TextBox 2"/>
-          <p:cNvSpPr txBox="1"/>
-          <p:nvPr/>
-        </p:nvSpPr>
-        <p:spPr>
-          <a:xfrm>
-            <a:off x="502920" y="658368"/>
-            <a:ext cx="10789920" cy="731520"/>
-          </a:xfrm>
-          <a:prstGeom prst="rect">
-            <a:avLst/>
-          </a:prstGeom>
-          <a:noFill/>
-        </p:spPr>
-        <p:txBody>
-          <a:bodyPr wrap="none">
-            <a:spAutoFit/>
-          </a:bodyPr>
-          <a:lstStyle/>
-          <a:p>
-            <a:pPr>
-              <a:defRPr sz="2800" b="1">
-                <a:solidFill>
-                  <a:srgbClr val="0B2545"/>
-                </a:solidFill>
-              </a:defRPr>
-            </a:pPr>
-            <a:r>
-              <a:t>AG News provides a balanced four-class classification task.</a:t>
-            </a:r>
-          </a:p>
-        </p:txBody>
-      </p:sp>
-      <p:sp>
-        <p:nvSpPr>
-          <p:cNvPr id="4" name="TextBox 3"/>
-          <p:cNvSpPr txBox="1"/>
-          <p:nvPr/>
-        </p:nvSpPr>
-        <p:spPr>
-          <a:xfrm>
-            <a:off x="822960" y="1691640"/>
-            <a:ext cx="10241280" cy="4389120"/>
-          </a:xfrm>
-          <a:prstGeom prst="rect">
-            <a:avLst/>
-          </a:prstGeom>
-          <a:noFill/>
-        </p:spPr>
-        <p:txBody>
-          <a:bodyPr wrap="square">
-            <a:spAutoFit/>
-          </a:bodyPr>
-          <a:lstStyle/>
-          <a:p>
-            <a:pPr>
-              <a:spcAft>
-                <a:spcPts val="800"/>
-              </a:spcAft>
-              <a:defRPr sz="2000">
-                <a:solidFill>
-                  <a:srgbClr val="232323"/>
-                </a:solidFill>
-              </a:defRPr>
-            </a:pPr>
-            <a:r>
-              <a:t>Source: Hugging Face fancyzhx/ag_news.</a:t>
-            </a:r>
-          </a:p>
-          <a:p>
-            <a:pPr>
-              <a:spcAft>
-                <a:spcPts val="800"/>
-              </a:spcAft>
-              <a:defRPr sz="2000">
-                <a:solidFill>
-                  <a:srgbClr val="232323"/>
-                </a:solidFill>
-              </a:defRPr>
-            </a:pPr>
-            <a:r>
-              <a:t>Split: 108,000 train, 12,000 validation, 7,600 official test.</a:t>
-            </a:r>
-          </a:p>
-          <a:p>
-            <a:pPr>
-              <a:spcAft>
-                <a:spcPts val="800"/>
-              </a:spcAft>
-              <a:defRPr sz="2000">
-                <a:solidFill>
-                  <a:srgbClr val="232323"/>
-                </a:solidFill>
-              </a:defRPr>
-            </a:pPr>
-            <a:r>
-              <a:t>Labels: World, Sports, Business, Sci/Tech.</a:t>
-            </a:r>
-          </a:p>
-        </p:txBody>
-      </p:sp>
-      <p:sp>
-        <p:nvSpPr>
-          <p:cNvPr id="5" name="TextBox 4"/>
-          <p:cNvSpPr txBox="1"/>
-          <p:nvPr/>
-        </p:nvSpPr>
-        <p:spPr>
-          <a:xfrm>
-            <a:off x="10881360" y="6355080"/>
-            <a:ext cx="640080" cy="182880"/>
-          </a:xfrm>
-          <a:prstGeom prst="rect">
-            <a:avLst/>
-          </a:prstGeom>
-          <a:noFill/>
-        </p:spPr>
-        <p:txBody>
-          <a:bodyPr wrap="none">
-            <a:spAutoFit/>
-          </a:bodyPr>
-          <a:lstStyle/>
-          <a:p>
-            <a:pPr algn="r">
-              <a:defRPr sz="800">
-                <a:solidFill>
-                  <a:srgbClr val="787878"/>
-                </a:solidFill>
-              </a:defRPr>
-            </a:pPr>
-            <a:r>
-              <a:t>2</a:t>
+              <a:t>2 of 11</a:t>
             </a:r>
           </a:p>
         </p:txBody>
@@ -3888,7 +4199,7 @@
     <p:bg>
       <p:bgPr>
         <a:solidFill>
-          <a:srgbClr val="FAFAF8"/>
+          <a:srgbClr val="FFFFFF"/>
         </a:solidFill>
         <a:effectLst/>
       </p:bgPr>
@@ -3908,8 +4219,8 @@
         </p:nvSpPr>
         <p:spPr>
           <a:xfrm>
-            <a:off x="502920" y="320040"/>
-            <a:ext cx="10789920" cy="320040"/>
+            <a:off x="73152" y="109728"/>
+            <a:ext cx="228600" cy="201168"/>
           </a:xfrm>
           <a:prstGeom prst="rect">
             <a:avLst/>
@@ -3923,14 +4234,14 @@
           <a:lstStyle/>
           <a:p>
             <a:pPr>
-              <a:defRPr sz="1000" b="1">
-                <a:solidFill>
-                  <a:srgbClr val="366092"/>
-                </a:solidFill>
-              </a:defRPr>
-            </a:pPr>
-            <a:r>
-              <a:t>SHARED PIPELINE</a:t>
+              <a:defRPr sz="1300" b="1">
+                <a:solidFill>
+                  <a:srgbClr val="1F4E79"/>
+                </a:solidFill>
+              </a:defRPr>
+            </a:pPr>
+            <a:r>
+              <a:t>3</a:t>
             </a:r>
           </a:p>
         </p:txBody>
@@ -3943,8 +4254,171 @@
         </p:nvSpPr>
         <p:spPr>
           <a:xfrm>
-            <a:off x="502920" y="658368"/>
-            <a:ext cx="10789920" cy="731520"/>
+            <a:off x="256032" y="146304"/>
+            <a:ext cx="8458200" cy="384048"/>
+          </a:xfrm>
+          <a:prstGeom prst="rect">
+            <a:avLst/>
+          </a:prstGeom>
+          <a:noFill/>
+        </p:spPr>
+        <p:txBody>
+          <a:bodyPr wrap="square">
+            <a:spAutoFit/>
+          </a:bodyPr>
+          <a:lstStyle/>
+          <a:p>
+            <a:pPr>
+              <a:defRPr sz="1700" b="1">
+                <a:solidFill>
+                  <a:srgbClr val="0B2545"/>
+                </a:solidFill>
+              </a:defRPr>
+            </a:pPr>
+            <a:r>
+              <a:t>Why compare LSTM and Transformer Encoder models?</a:t>
+            </a:r>
+          </a:p>
+        </p:txBody>
+      </p:sp>
+      <p:sp>
+        <p:nvSpPr>
+          <p:cNvPr id="4" name="Rectangle 3"/>
+          <p:cNvSpPr/>
+          <p:nvPr/>
+        </p:nvSpPr>
+        <p:spPr>
+          <a:xfrm>
+            <a:off x="256032" y="530352"/>
+            <a:ext cx="8458200" cy="18288"/>
+          </a:xfrm>
+          <a:prstGeom prst="rect">
+            <a:avLst/>
+          </a:prstGeom>
+          <a:solidFill>
+            <a:srgbClr val="1F4E79"/>
+          </a:solidFill>
+          <a:ln>
+            <a:solidFill>
+              <a:srgbClr val="1F4E79"/>
+            </a:solidFill>
+          </a:ln>
+        </p:spPr>
+        <p:style>
+          <a:lnRef idx="1">
+            <a:schemeClr val="accent1"/>
+          </a:lnRef>
+          <a:fillRef idx="3">
+            <a:schemeClr val="accent1"/>
+          </a:fillRef>
+          <a:effectRef idx="2">
+            <a:schemeClr val="accent1"/>
+          </a:effectRef>
+          <a:fontRef idx="minor">
+            <a:schemeClr val="lt1"/>
+          </a:fontRef>
+        </p:style>
+        <p:txBody>
+          <a:bodyPr rtlCol="0" anchor="ctr"/>
+          <a:lstStyle/>
+          <a:p>
+            <a:pPr algn="ctr"/>
+          </a:p>
+        </p:txBody>
+      </p:sp>
+      <p:sp>
+        <p:nvSpPr>
+          <p:cNvPr id="5" name="TextBox 4"/>
+          <p:cNvSpPr txBox="1"/>
+          <p:nvPr/>
+        </p:nvSpPr>
+        <p:spPr>
+          <a:xfrm>
+            <a:off x="685800" y="960120"/>
+            <a:ext cx="7772400" cy="5212080"/>
+          </a:xfrm>
+          <a:prstGeom prst="rect">
+            <a:avLst/>
+          </a:prstGeom>
+          <a:noFill/>
+        </p:spPr>
+        <p:txBody>
+          <a:bodyPr wrap="square">
+            <a:spAutoFit/>
+          </a:bodyPr>
+          <a:lstStyle/>
+          <a:p>
+            <a:pPr>
+              <a:spcAft>
+                <a:spcPts val="500"/>
+              </a:spcAft>
+              <a:defRPr sz="1200">
+                <a:solidFill>
+                  <a:srgbClr val="232323"/>
+                </a:solidFill>
+              </a:defRPr>
+            </a:pPr>
+            <a:r>
+              <a:t>Both models are common sequence classifiers, but they process text differently.</a:t>
+            </a:r>
+          </a:p>
+          <a:p>
+            <a:pPr>
+              <a:spcAft>
+                <a:spcPts val="500"/>
+              </a:spcAft>
+              <a:defRPr sz="1200">
+                <a:solidFill>
+                  <a:srgbClr val="232323"/>
+                </a:solidFill>
+              </a:defRPr>
+            </a:pPr>
+            <a:r>
+              <a:t>The LSTM carries information recurrently through hidden states.</a:t>
+            </a:r>
+          </a:p>
+          <a:p>
+            <a:pPr>
+              <a:spcAft>
+                <a:spcPts val="500"/>
+              </a:spcAft>
+              <a:defRPr sz="1200">
+                <a:solidFill>
+                  <a:srgbClr val="232323"/>
+                </a:solidFill>
+              </a:defRPr>
+            </a:pPr>
+            <a:r>
+              <a:t>The Transformer Encoder uses self-attention to connect tokens directly.</a:t>
+            </a:r>
+          </a:p>
+          <a:p>
+            <a:pPr>
+              <a:spcAft>
+                <a:spcPts val="500"/>
+              </a:spcAft>
+              <a:defRPr sz="1200">
+                <a:solidFill>
+                  <a:srgbClr val="232323"/>
+                </a:solidFill>
+              </a:defRPr>
+            </a:pPr>
+            <a:r>
+              <a:t>The goal is to compare behavior, not only final accuracy.</a:t>
+            </a:r>
+          </a:p>
+        </p:txBody>
+      </p:sp>
+      <p:sp>
+        <p:nvSpPr>
+          <p:cNvPr id="6" name="TextBox 5"/>
+          <p:cNvSpPr txBox="1"/>
+          <p:nvPr/>
+        </p:nvSpPr>
+        <p:spPr>
+          <a:xfrm>
+            <a:off x="109728" y="6565392"/>
+            <a:ext cx="3200400" cy="146304"/>
           </a:xfrm>
           <a:prstGeom prst="rect">
             <a:avLst/>
@@ -3958,111 +4432,28 @@
           <a:lstStyle/>
           <a:p>
             <a:pPr>
-              <a:defRPr sz="2800" b="1">
-                <a:solidFill>
-                  <a:srgbClr val="0B2545"/>
-                </a:solidFill>
-              </a:defRPr>
-            </a:pPr>
-            <a:r>
-              <a:t>Both models receive the same processed inputs.</a:t>
-            </a:r>
-          </a:p>
-        </p:txBody>
-      </p:sp>
-      <p:sp>
-        <p:nvSpPr>
-          <p:cNvPr id="4" name="TextBox 3"/>
+              <a:defRPr sz="550">
+                <a:solidFill>
+                  <a:srgbClr val="1F4E79"/>
+                </a:solidFill>
+              </a:defRPr>
+            </a:pPr>
+            <a:r>
+              <a:t>Advanced Battery Manufacturing Systems</a:t>
+            </a:r>
+          </a:p>
+        </p:txBody>
+      </p:sp>
+      <p:sp>
+        <p:nvSpPr>
+          <p:cNvPr id="7" name="TextBox 6"/>
           <p:cNvSpPr txBox="1"/>
           <p:nvPr/>
         </p:nvSpPr>
         <p:spPr>
           <a:xfrm>
-            <a:off x="822960" y="1691640"/>
-            <a:ext cx="10241280" cy="4389120"/>
-          </a:xfrm>
-          <a:prstGeom prst="rect">
-            <a:avLst/>
-          </a:prstGeom>
-          <a:noFill/>
-        </p:spPr>
-        <p:txBody>
-          <a:bodyPr wrap="square">
-            <a:spAutoFit/>
-          </a:bodyPr>
-          <a:lstStyle/>
-          <a:p>
-            <a:pPr>
-              <a:spcAft>
-                <a:spcPts val="800"/>
-              </a:spcAft>
-              <a:defRPr sz="2000">
-                <a:solidFill>
-                  <a:srgbClr val="232323"/>
-                </a:solidFill>
-              </a:defRPr>
-            </a:pPr>
-            <a:r>
-              <a:t>Regex tokenizer and train-only vocabulary.</a:t>
-            </a:r>
-          </a:p>
-          <a:p>
-            <a:pPr>
-              <a:spcAft>
-                <a:spcPts val="800"/>
-              </a:spcAft>
-              <a:defRPr sz="2000">
-                <a:solidFill>
-                  <a:srgbClr val="232323"/>
-                </a:solidFill>
-              </a:defRPr>
-            </a:pPr>
-            <a:r>
-              <a:t>Vocabulary size: 20,000 tokens.</a:t>
-            </a:r>
-          </a:p>
-          <a:p>
-            <a:pPr>
-              <a:spcAft>
-                <a:spcPts val="800"/>
-              </a:spcAft>
-              <a:defRPr sz="2000">
-                <a:solidFill>
-                  <a:srgbClr val="232323"/>
-                </a:solidFill>
-              </a:defRPr>
-            </a:pPr>
-            <a:r>
-              <a:t>Maximum sequence length: 128 for the main comparison.</a:t>
-            </a:r>
-          </a:p>
-          <a:p>
-            <a:pPr>
-              <a:spcAft>
-                <a:spcPts val="800"/>
-              </a:spcAft>
-              <a:defRPr sz="2000">
-                <a:solidFill>
-                  <a:srgbClr val="232323"/>
-                </a:solidFill>
-              </a:defRPr>
-            </a:pPr>
-            <a:r>
-              <a:t>Padding masks used during pooling and attention.</a:t>
-            </a:r>
-          </a:p>
-        </p:txBody>
-      </p:sp>
-      <p:sp>
-        <p:nvSpPr>
-          <p:cNvPr id="5" name="TextBox 4"/>
-          <p:cNvSpPr txBox="1"/>
-          <p:nvPr/>
-        </p:nvSpPr>
-        <p:spPr>
-          <a:xfrm>
-            <a:off x="10881360" y="6355080"/>
-            <a:ext cx="640080" cy="182880"/>
+            <a:off x="8412480" y="6565392"/>
+            <a:ext cx="502920" cy="146304"/>
           </a:xfrm>
           <a:prstGeom prst="rect">
             <a:avLst/>
@@ -4076,14 +4467,14 @@
           <a:lstStyle/>
           <a:p>
             <a:pPr algn="r">
-              <a:defRPr sz="800">
+              <a:defRPr sz="550">
                 <a:solidFill>
                   <a:srgbClr val="787878"/>
                 </a:solidFill>
               </a:defRPr>
             </a:pPr>
             <a:r>
-              <a:t>3</a:t>
+              <a:t>3 of 11</a:t>
             </a:r>
           </a:p>
         </p:txBody>
@@ -4102,7 +4493,7 @@
     <p:bg>
       <p:bgPr>
         <a:solidFill>
-          <a:srgbClr val="FAFAF8"/>
+          <a:srgbClr val="FFFFFF"/>
         </a:solidFill>
         <a:effectLst/>
       </p:bgPr>
@@ -4122,8 +4513,8 @@
         </p:nvSpPr>
         <p:spPr>
           <a:xfrm>
-            <a:off x="502920" y="320040"/>
-            <a:ext cx="10789920" cy="320040"/>
+            <a:off x="73152" y="109728"/>
+            <a:ext cx="228600" cy="201168"/>
           </a:xfrm>
           <a:prstGeom prst="rect">
             <a:avLst/>
@@ -4137,14 +4528,14 @@
           <a:lstStyle/>
           <a:p>
             <a:pPr>
-              <a:defRPr sz="1000" b="1">
-                <a:solidFill>
-                  <a:srgbClr val="366092"/>
-                </a:solidFill>
-              </a:defRPr>
-            </a:pPr>
-            <a:r>
-              <a:t>ARCHITECTURES</a:t>
+              <a:defRPr sz="1300" b="1">
+                <a:solidFill>
+                  <a:srgbClr val="1F4E79"/>
+                </a:solidFill>
+              </a:defRPr>
+            </a:pPr>
+            <a:r>
+              <a:t>4</a:t>
             </a:r>
           </a:p>
         </p:txBody>
@@ -4157,8 +4548,8 @@
         </p:nvSpPr>
         <p:spPr>
           <a:xfrm>
-            <a:off x="502920" y="658368"/>
-            <a:ext cx="10789920" cy="731520"/>
+            <a:off x="256032" y="146304"/>
+            <a:ext cx="8458200" cy="384048"/>
           </a:xfrm>
           <a:prstGeom prst="rect">
             <a:avLst/>
@@ -4166,20 +4557,20 @@
           <a:noFill/>
         </p:spPr>
         <p:txBody>
-          <a:bodyPr wrap="none">
+          <a:bodyPr wrap="square">
             <a:spAutoFit/>
           </a:bodyPr>
           <a:lstStyle/>
           <a:p>
             <a:pPr>
-              <a:defRPr sz="2800" b="1">
+              <a:defRPr sz="1700" b="1">
                 <a:solidFill>
                   <a:srgbClr val="0B2545"/>
                 </a:solidFill>
               </a:defRPr>
             </a:pPr>
             <a:r>
-              <a:t>Different sequence models, comparable parameter scale.</a:t>
+              <a:t>AG News provides a controlled four-class text classification task.</a:t>
             </a:r>
           </a:p>
         </p:txBody>
@@ -4192,18 +4583,18 @@
         </p:nvSpPr>
         <p:spPr>
           <a:xfrm>
-            <a:off x="685800" y="1828800"/>
-            <a:ext cx="2240280" cy="1097280"/>
+            <a:off x="256032" y="530352"/>
+            <a:ext cx="8458200" cy="18288"/>
           </a:xfrm>
           <a:prstGeom prst="rect">
             <a:avLst/>
           </a:prstGeom>
           <a:solidFill>
-            <a:srgbClr val="F2F4F7"/>
+            <a:srgbClr val="1F4E79"/>
           </a:solidFill>
           <a:ln>
             <a:solidFill>
-              <a:srgbClr val="D2D8E0"/>
+              <a:srgbClr val="1F4E79"/>
             </a:solidFill>
           </a:ln>
         </p:spPr>
@@ -4225,51 +4616,279 @@
           <a:bodyPr rtlCol="0" anchor="ctr"/>
           <a:lstStyle/>
           <a:p>
-            <a:pPr algn="ctr">
-              <a:defRPr sz="2400" b="1">
-                <a:solidFill>
-                  <a:srgbClr val="2E74B5"/>
-                </a:solidFill>
-              </a:defRPr>
-            </a:pPr>
-            <a:r>
-              <a:t>2.83M</a:t>
-            </a:r>
-          </a:p>
-          <a:p>
-            <a:pPr algn="ctr">
-              <a:defRPr sz="1100">
-                <a:solidFill>
-                  <a:srgbClr val="464646"/>
-                </a:solidFill>
-              </a:defRPr>
-            </a:pPr>
-            <a:r>
-              <a:t>LSTM parameters</a:t>
-            </a:r>
-          </a:p>
-        </p:txBody>
-      </p:sp>
-      <p:sp>
-        <p:nvSpPr>
-          <p:cNvPr id="5" name="Rectangle 4"/>
+            <a:pPr algn="ctr"/>
+          </a:p>
+        </p:txBody>
+      </p:sp>
+      <p:sp>
+        <p:nvSpPr>
+          <p:cNvPr id="5" name="TextBox 4"/>
+          <p:cNvSpPr txBox="1"/>
+          <p:nvPr/>
+        </p:nvSpPr>
+        <p:spPr>
+          <a:xfrm>
+            <a:off x="685800" y="960120"/>
+            <a:ext cx="7772400" cy="5212080"/>
+          </a:xfrm>
+          <a:prstGeom prst="rect">
+            <a:avLst/>
+          </a:prstGeom>
+          <a:noFill/>
+        </p:spPr>
+        <p:txBody>
+          <a:bodyPr wrap="square">
+            <a:spAutoFit/>
+          </a:bodyPr>
+          <a:lstStyle/>
+          <a:p>
+            <a:pPr>
+              <a:spcAft>
+                <a:spcPts val="500"/>
+              </a:spcAft>
+              <a:defRPr sz="1200">
+                <a:solidFill>
+                  <a:srgbClr val="232323"/>
+                </a:solidFill>
+              </a:defRPr>
+            </a:pPr>
+            <a:r>
+              <a:t>Dataset source: Hugging Face fancyzhx/ag_news only.</a:t>
+            </a:r>
+          </a:p>
+          <a:p>
+            <a:pPr>
+              <a:spcAft>
+                <a:spcPts val="500"/>
+              </a:spcAft>
+              <a:defRPr sz="1200">
+                <a:solidFill>
+                  <a:srgbClr val="232323"/>
+                </a:solidFill>
+              </a:defRPr>
+            </a:pPr>
+            <a:r>
+              <a:t>Classes: World, Sports, Business, and Sci/Tech.</a:t>
+            </a:r>
+          </a:p>
+          <a:p>
+            <a:pPr>
+              <a:spcAft>
+                <a:spcPts val="500"/>
+              </a:spcAft>
+              <a:defRPr sz="1200">
+                <a:solidFill>
+                  <a:srgbClr val="232323"/>
+                </a:solidFill>
+              </a:defRPr>
+            </a:pPr>
+            <a:r>
+              <a:t>Split: 108,000 train, 12,000 validation, and 7,600 official test examples.</a:t>
+            </a:r>
+          </a:p>
+          <a:p>
+            <a:pPr>
+              <a:spcAft>
+                <a:spcPts val="500"/>
+              </a:spcAft>
+              <a:defRPr sz="1200">
+                <a:solidFill>
+                  <a:srgbClr val="232323"/>
+                </a:solidFill>
+              </a:defRPr>
+            </a:pPr>
+            <a:r>
+              <a:t>The official test set is used only for final evaluation.</a:t>
+            </a:r>
+          </a:p>
+        </p:txBody>
+      </p:sp>
+      <p:sp>
+        <p:nvSpPr>
+          <p:cNvPr id="6" name="TextBox 5"/>
+          <p:cNvSpPr txBox="1"/>
+          <p:nvPr/>
+        </p:nvSpPr>
+        <p:spPr>
+          <a:xfrm>
+            <a:off x="109728" y="6565392"/>
+            <a:ext cx="3200400" cy="146304"/>
+          </a:xfrm>
+          <a:prstGeom prst="rect">
+            <a:avLst/>
+          </a:prstGeom>
+          <a:noFill/>
+        </p:spPr>
+        <p:txBody>
+          <a:bodyPr wrap="none">
+            <a:spAutoFit/>
+          </a:bodyPr>
+          <a:lstStyle/>
+          <a:p>
+            <a:pPr>
+              <a:defRPr sz="550">
+                <a:solidFill>
+                  <a:srgbClr val="1F4E79"/>
+                </a:solidFill>
+              </a:defRPr>
+            </a:pPr>
+            <a:r>
+              <a:t>Advanced Battery Manufacturing Systems</a:t>
+            </a:r>
+          </a:p>
+        </p:txBody>
+      </p:sp>
+      <p:sp>
+        <p:nvSpPr>
+          <p:cNvPr id="7" name="TextBox 6"/>
+          <p:cNvSpPr txBox="1"/>
+          <p:nvPr/>
+        </p:nvSpPr>
+        <p:spPr>
+          <a:xfrm>
+            <a:off x="8412480" y="6565392"/>
+            <a:ext cx="502920" cy="146304"/>
+          </a:xfrm>
+          <a:prstGeom prst="rect">
+            <a:avLst/>
+          </a:prstGeom>
+          <a:noFill/>
+        </p:spPr>
+        <p:txBody>
+          <a:bodyPr wrap="none">
+            <a:spAutoFit/>
+          </a:bodyPr>
+          <a:lstStyle/>
+          <a:p>
+            <a:pPr algn="r">
+              <a:defRPr sz="550">
+                <a:solidFill>
+                  <a:srgbClr val="787878"/>
+                </a:solidFill>
+              </a:defRPr>
+            </a:pPr>
+            <a:r>
+              <a:t>4 of 11</a:t>
+            </a:r>
+          </a:p>
+        </p:txBody>
+      </p:sp>
+    </p:spTree>
+  </p:cSld>
+  <p:clrMapOvr>
+    <a:masterClrMapping/>
+  </p:clrMapOvr>
+</p:sld>
+</file>
+
+<file path=ppt/slides/slide5.xml><?xml version="1.0" encoding="utf-8"?>
+<p:sld xmlns:a="http://schemas.openxmlformats.org/drawingml/2006/main" xmlns:p="http://schemas.openxmlformats.org/presentationml/2006/main" xmlns:r="http://schemas.openxmlformats.org/officeDocument/2006/relationships">
+  <p:cSld>
+    <p:bg>
+      <p:bgPr>
+        <a:solidFill>
+          <a:srgbClr val="FFFFFF"/>
+        </a:solidFill>
+        <a:effectLst/>
+      </p:bgPr>
+    </p:bg>
+    <p:spTree>
+      <p:nvGrpSpPr>
+        <p:cNvPr id="1" name=""/>
+        <p:cNvGrpSpPr/>
+        <p:nvPr/>
+      </p:nvGrpSpPr>
+      <p:grpSpPr/>
+      <p:sp>
+        <p:nvSpPr>
+          <p:cNvPr id="2" name="TextBox 1"/>
+          <p:cNvSpPr txBox="1"/>
+          <p:nvPr/>
+        </p:nvSpPr>
+        <p:spPr>
+          <a:xfrm>
+            <a:off x="73152" y="109728"/>
+            <a:ext cx="228600" cy="201168"/>
+          </a:xfrm>
+          <a:prstGeom prst="rect">
+            <a:avLst/>
+          </a:prstGeom>
+          <a:noFill/>
+        </p:spPr>
+        <p:txBody>
+          <a:bodyPr wrap="none">
+            <a:spAutoFit/>
+          </a:bodyPr>
+          <a:lstStyle/>
+          <a:p>
+            <a:pPr>
+              <a:defRPr sz="1300" b="1">
+                <a:solidFill>
+                  <a:srgbClr val="1F4E79"/>
+                </a:solidFill>
+              </a:defRPr>
+            </a:pPr>
+            <a:r>
+              <a:t>5</a:t>
+            </a:r>
+          </a:p>
+        </p:txBody>
+      </p:sp>
+      <p:sp>
+        <p:nvSpPr>
+          <p:cNvPr id="3" name="TextBox 2"/>
+          <p:cNvSpPr txBox="1"/>
+          <p:nvPr/>
+        </p:nvSpPr>
+        <p:spPr>
+          <a:xfrm>
+            <a:off x="256032" y="146304"/>
+            <a:ext cx="8458200" cy="384048"/>
+          </a:xfrm>
+          <a:prstGeom prst="rect">
+            <a:avLst/>
+          </a:prstGeom>
+          <a:noFill/>
+        </p:spPr>
+        <p:txBody>
+          <a:bodyPr wrap="square">
+            <a:spAutoFit/>
+          </a:bodyPr>
+          <a:lstStyle/>
+          <a:p>
+            <a:pPr>
+              <a:defRPr sz="1700" b="1">
+                <a:solidFill>
+                  <a:srgbClr val="0B2545"/>
+                </a:solidFill>
+              </a:defRPr>
+            </a:pPr>
+            <a:r>
+              <a:t>Both models use the same processed input pipeline.</a:t>
+            </a:r>
+          </a:p>
+        </p:txBody>
+      </p:sp>
+      <p:sp>
+        <p:nvSpPr>
+          <p:cNvPr id="4" name="Rectangle 3"/>
           <p:cNvSpPr/>
           <p:nvPr/>
         </p:nvSpPr>
         <p:spPr>
           <a:xfrm>
-            <a:off x="3154680" y="1828800"/>
-            <a:ext cx="2240280" cy="1097280"/>
+            <a:off x="256032" y="530352"/>
+            <a:ext cx="8458200" cy="18288"/>
           </a:xfrm>
           <a:prstGeom prst="rect">
             <a:avLst/>
           </a:prstGeom>
           <a:solidFill>
-            <a:srgbClr val="F2F4F7"/>
+            <a:srgbClr val="1F4E79"/>
           </a:solidFill>
           <a:ln>
             <a:solidFill>
-              <a:srgbClr val="D2D8E0"/>
+              <a:srgbClr val="1F4E79"/>
             </a:solidFill>
           </a:ln>
         </p:spPr>
@@ -4291,41 +4910,20 @@
           <a:bodyPr rtlCol="0" anchor="ctr"/>
           <a:lstStyle/>
           <a:p>
-            <a:pPr algn="ctr">
-              <a:defRPr sz="2400" b="1">
-                <a:solidFill>
-                  <a:srgbClr val="2E74B5"/>
-                </a:solidFill>
-              </a:defRPr>
-            </a:pPr>
-            <a:r>
-              <a:t>2.97M</a:t>
-            </a:r>
-          </a:p>
-          <a:p>
-            <a:pPr algn="ctr">
-              <a:defRPr sz="1100">
-                <a:solidFill>
-                  <a:srgbClr val="464646"/>
-                </a:solidFill>
-              </a:defRPr>
-            </a:pPr>
-            <a:r>
-              <a:t>Transformer parameters</a:t>
-            </a:r>
-          </a:p>
-        </p:txBody>
-      </p:sp>
-      <p:sp>
-        <p:nvSpPr>
-          <p:cNvPr id="6" name="TextBox 5"/>
+            <a:pPr algn="ctr"/>
+          </a:p>
+        </p:txBody>
+      </p:sp>
+      <p:sp>
+        <p:nvSpPr>
+          <p:cNvPr id="5" name="TextBox 4"/>
           <p:cNvSpPr txBox="1"/>
           <p:nvPr/>
         </p:nvSpPr>
         <p:spPr>
           <a:xfrm>
-            <a:off x="777240" y="3246120"/>
-            <a:ext cx="10058400" cy="1828800"/>
+            <a:off x="685800" y="960120"/>
+            <a:ext cx="7772400" cy="5212080"/>
           </a:xfrm>
           <a:prstGeom prst="rect">
             <a:avLst/>
@@ -4340,60 +4938,75 @@
           <a:p>
             <a:pPr>
               <a:spcAft>
-                <a:spcPts val="800"/>
+                <a:spcPts val="500"/>
               </a:spcAft>
-              <a:defRPr sz="1800">
+              <a:defRPr sz="1200">
                 <a:solidFill>
                   <a:srgbClr val="232323"/>
                 </a:solidFill>
               </a:defRPr>
             </a:pPr>
             <a:r>
-              <a:t>LSTM: bidirectional one-layer recurrent encoder with masked mean pooling.</a:t>
+              <a:t>Regex tokenizer and train-only vocabulary construction.</a:t>
             </a:r>
           </a:p>
           <a:p>
             <a:pPr>
               <a:spcAft>
-                <a:spcPts val="800"/>
+                <a:spcPts val="500"/>
               </a:spcAft>
-              <a:defRPr sz="1800">
+              <a:defRPr sz="1200">
                 <a:solidFill>
                   <a:srgbClr val="232323"/>
                 </a:solidFill>
               </a:defRPr>
             </a:pPr>
             <a:r>
-              <a:t>Transformer Encoder: two layers, four heads, learned positional embeddings.</a:t>
+              <a:t>Vocabulary size capped at 20,000 tokens.</a:t>
             </a:r>
           </a:p>
           <a:p>
             <a:pPr>
               <a:spcAft>
-                <a:spcPts val="800"/>
+                <a:spcPts val="500"/>
               </a:spcAft>
-              <a:defRPr sz="1800">
+              <a:defRPr sz="1200">
                 <a:solidFill>
                   <a:srgbClr val="232323"/>
                 </a:solidFill>
               </a:defRPr>
             </a:pPr>
             <a:r>
-              <a:t>Parameter counts are close enough for a fair introductory comparison.</a:t>
-            </a:r>
-          </a:p>
-        </p:txBody>
-      </p:sp>
-      <p:sp>
-        <p:nvSpPr>
-          <p:cNvPr id="7" name="TextBox 6"/>
+              <a:t>Maximum sequence length is 128 for the main comparison.</a:t>
+            </a:r>
+          </a:p>
+          <a:p>
+            <a:pPr>
+              <a:spcAft>
+                <a:spcPts val="500"/>
+              </a:spcAft>
+              <a:defRPr sz="1200">
+                <a:solidFill>
+                  <a:srgbClr val="232323"/>
+                </a:solidFill>
+              </a:defRPr>
+            </a:pPr>
+            <a:r>
+              <a:t>Padding masks are used during LSTM pooling and Transformer attention.</a:t>
+            </a:r>
+          </a:p>
+        </p:txBody>
+      </p:sp>
+      <p:sp>
+        <p:nvSpPr>
+          <p:cNvPr id="6" name="TextBox 5"/>
           <p:cNvSpPr txBox="1"/>
           <p:nvPr/>
         </p:nvSpPr>
         <p:spPr>
           <a:xfrm>
-            <a:off x="10881360" y="6355080"/>
-            <a:ext cx="640080" cy="182880"/>
+            <a:off x="109728" y="6565392"/>
+            <a:ext cx="3200400" cy="146304"/>
           </a:xfrm>
           <a:prstGeom prst="rect">
             <a:avLst/>
@@ -4406,55 +5019,29 @@
           </a:bodyPr>
           <a:lstStyle/>
           <a:p>
-            <a:pPr algn="r">
-              <a:defRPr sz="800">
-                <a:solidFill>
-                  <a:srgbClr val="787878"/>
-                </a:solidFill>
-              </a:defRPr>
-            </a:pPr>
-            <a:r>
-              <a:t>4</a:t>
-            </a:r>
-          </a:p>
-        </p:txBody>
-      </p:sp>
-    </p:spTree>
-  </p:cSld>
-  <p:clrMapOvr>
-    <a:masterClrMapping/>
-  </p:clrMapOvr>
-</p:sld>
-</file>
-
-<file path=ppt/slides/slide5.xml><?xml version="1.0" encoding="utf-8"?>
-<p:sld xmlns:a="http://schemas.openxmlformats.org/drawingml/2006/main" xmlns:p="http://schemas.openxmlformats.org/presentationml/2006/main" xmlns:r="http://schemas.openxmlformats.org/officeDocument/2006/relationships">
-  <p:cSld>
-    <p:bg>
-      <p:bgPr>
-        <a:solidFill>
-          <a:srgbClr val="FAFAF8"/>
-        </a:solidFill>
-        <a:effectLst/>
-      </p:bgPr>
-    </p:bg>
-    <p:spTree>
-      <p:nvGrpSpPr>
-        <p:cNvPr id="1" name=""/>
-        <p:cNvGrpSpPr/>
-        <p:nvPr/>
-      </p:nvGrpSpPr>
-      <p:grpSpPr/>
-      <p:sp>
-        <p:nvSpPr>
-          <p:cNvPr id="2" name="TextBox 1"/>
+            <a:pPr>
+              <a:defRPr sz="550">
+                <a:solidFill>
+                  <a:srgbClr val="1F4E79"/>
+                </a:solidFill>
+              </a:defRPr>
+            </a:pPr>
+            <a:r>
+              <a:t>Advanced Battery Manufacturing Systems</a:t>
+            </a:r>
+          </a:p>
+        </p:txBody>
+      </p:sp>
+      <p:sp>
+        <p:nvSpPr>
+          <p:cNvPr id="7" name="TextBox 6"/>
           <p:cNvSpPr txBox="1"/>
           <p:nvPr/>
         </p:nvSpPr>
         <p:spPr>
           <a:xfrm>
-            <a:off x="502920" y="320040"/>
-            <a:ext cx="10789920" cy="320040"/>
+            <a:off x="8412480" y="6565392"/>
+            <a:ext cx="502920" cy="146304"/>
           </a:xfrm>
           <a:prstGeom prst="rect">
             <a:avLst/>
@@ -4467,177 +5054,15 @@
           </a:bodyPr>
           <a:lstStyle/>
           <a:p>
-            <a:pPr>
-              <a:defRPr sz="1000" b="1">
-                <a:solidFill>
-                  <a:srgbClr val="366092"/>
-                </a:solidFill>
-              </a:defRPr>
-            </a:pPr>
-            <a:r>
-              <a:t>MAIN RESULT</a:t>
-            </a:r>
-          </a:p>
-        </p:txBody>
-      </p:sp>
-      <p:sp>
-        <p:nvSpPr>
-          <p:cNvPr id="3" name="TextBox 2"/>
-          <p:cNvSpPr txBox="1"/>
-          <p:nvPr/>
-        </p:nvSpPr>
-        <p:spPr>
-          <a:xfrm>
-            <a:off x="502920" y="658368"/>
-            <a:ext cx="10789920" cy="731520"/>
-          </a:xfrm>
-          <a:prstGeom prst="rect">
-            <a:avLst/>
-          </a:prstGeom>
-          <a:noFill/>
-        </p:spPr>
-        <p:txBody>
-          <a:bodyPr wrap="none">
-            <a:spAutoFit/>
-          </a:bodyPr>
-          <a:lstStyle/>
-          <a:p>
-            <a:pPr>
-              <a:defRPr sz="2800" b="1">
-                <a:solidFill>
-                  <a:srgbClr val="0B2545"/>
-                </a:solidFill>
-              </a:defRPr>
-            </a:pPr>
-            <a:r>
-              <a:t>Both models are close; Transformer Encoder has a slight final edge.</a:t>
-            </a:r>
-          </a:p>
-        </p:txBody>
-      </p:sp>
-      <p:pic>
-        <p:nvPicPr>
-          <p:cNvPr id="4" name="Picture 3" descr="main_loss_curves.png"/>
-          <p:cNvPicPr>
-            <a:picLocks noChangeAspect="1"/>
-          </p:cNvPicPr>
-          <p:nvPr/>
-        </p:nvPicPr>
-        <p:blipFill>
-          <a:blip r:embed="rId2"/>
-          <a:stretch>
-            <a:fillRect/>
-          </a:stretch>
-        </p:blipFill>
-        <p:spPr>
-          <a:xfrm>
-            <a:off x="6217920" y="1508760"/>
-            <a:ext cx="4983480" cy="3114675"/>
-          </a:xfrm>
-          <a:prstGeom prst="rect">
-            <a:avLst/>
-          </a:prstGeom>
-        </p:spPr>
-      </p:pic>
-      <p:sp>
-        <p:nvSpPr>
-          <p:cNvPr id="5" name="TextBox 4"/>
-          <p:cNvSpPr txBox="1"/>
-          <p:nvPr/>
-        </p:nvSpPr>
-        <p:spPr>
-          <a:xfrm>
-            <a:off x="685800" y="1600200"/>
-            <a:ext cx="5120640" cy="4297680"/>
-          </a:xfrm>
-          <a:prstGeom prst="rect">
-            <a:avLst/>
-          </a:prstGeom>
-          <a:noFill/>
-        </p:spPr>
-        <p:txBody>
-          <a:bodyPr wrap="square">
-            <a:spAutoFit/>
-          </a:bodyPr>
-          <a:lstStyle/>
-          <a:p>
-            <a:pPr>
-              <a:spcAft>
-                <a:spcPts val="800"/>
-              </a:spcAft>
-              <a:defRPr sz="1700">
-                <a:solidFill>
-                  <a:srgbClr val="232323"/>
-                </a:solidFill>
-              </a:defRPr>
-            </a:pPr>
-            <a:r>
-              <a:t>LSTM test accuracy 0.9120 and macro F1 0.9118.</a:t>
-            </a:r>
-          </a:p>
-          <a:p>
-            <a:pPr>
-              <a:spcAft>
-                <a:spcPts val="800"/>
-              </a:spcAft>
-              <a:defRPr sz="1700">
-                <a:solidFill>
-                  <a:srgbClr val="232323"/>
-                </a:solidFill>
-              </a:defRPr>
-            </a:pPr>
-            <a:r>
-              <a:t>Transformer test accuracy 0.9125 and macro F1 0.9126.</a:t>
-            </a:r>
-          </a:p>
-          <a:p>
-            <a:pPr>
-              <a:spcAft>
-                <a:spcPts val="800"/>
-              </a:spcAft>
-              <a:defRPr sz="1700">
-                <a:solidFill>
-                  <a:srgbClr val="232323"/>
-                </a:solidFill>
-              </a:defRPr>
-            </a:pPr>
-            <a:r>
-              <a:t>The margin is small, so the conclusion should be cautious.</a:t>
-            </a:r>
-          </a:p>
-        </p:txBody>
-      </p:sp>
-      <p:sp>
-        <p:nvSpPr>
-          <p:cNvPr id="6" name="TextBox 5"/>
-          <p:cNvSpPr txBox="1"/>
-          <p:nvPr/>
-        </p:nvSpPr>
-        <p:spPr>
-          <a:xfrm>
-            <a:off x="10881360" y="6355080"/>
-            <a:ext cx="640080" cy="182880"/>
-          </a:xfrm>
-          <a:prstGeom prst="rect">
-            <a:avLst/>
-          </a:prstGeom>
-          <a:noFill/>
-        </p:spPr>
-        <p:txBody>
-          <a:bodyPr wrap="none">
-            <a:spAutoFit/>
-          </a:bodyPr>
-          <a:lstStyle/>
-          <a:p>
             <a:pPr algn="r">
-              <a:defRPr sz="800">
+              <a:defRPr sz="550">
                 <a:solidFill>
                   <a:srgbClr val="787878"/>
                 </a:solidFill>
               </a:defRPr>
             </a:pPr>
             <a:r>
-              <a:t>5</a:t>
+              <a:t>5 of 11</a:t>
             </a:r>
           </a:p>
         </p:txBody>
@@ -4656,7 +5081,7 @@
     <p:bg>
       <p:bgPr>
         <a:solidFill>
-          <a:srgbClr val="FAFAF8"/>
+          <a:srgbClr val="FFFFFF"/>
         </a:solidFill>
         <a:effectLst/>
       </p:bgPr>
@@ -4676,8 +5101,8 @@
         </p:nvSpPr>
         <p:spPr>
           <a:xfrm>
-            <a:off x="502920" y="320040"/>
-            <a:ext cx="10789920" cy="320040"/>
+            <a:off x="73152" y="109728"/>
+            <a:ext cx="228600" cy="201168"/>
           </a:xfrm>
           <a:prstGeom prst="rect">
             <a:avLst/>
@@ -4691,14 +5116,14 @@
           <a:lstStyle/>
           <a:p>
             <a:pPr>
-              <a:defRPr sz="1000" b="1">
-                <a:solidFill>
-                  <a:srgbClr val="366092"/>
-                </a:solidFill>
-              </a:defRPr>
-            </a:pPr>
-            <a:r>
-              <a:t>TRAINING BEHAVIOR</a:t>
+              <a:defRPr sz="1300" b="1">
+                <a:solidFill>
+                  <a:srgbClr val="1F4E79"/>
+                </a:solidFill>
+              </a:defRPr>
+            </a:pPr>
+            <a:r>
+              <a:t>6</a:t>
             </a:r>
           </a:p>
         </p:txBody>
@@ -4711,8 +5136,303 @@
         </p:nvSpPr>
         <p:spPr>
           <a:xfrm>
-            <a:off x="502920" y="658368"/>
-            <a:ext cx="10789920" cy="731520"/>
+            <a:off x="256032" y="146304"/>
+            <a:ext cx="8458200" cy="384048"/>
+          </a:xfrm>
+          <a:prstGeom prst="rect">
+            <a:avLst/>
+          </a:prstGeom>
+          <a:noFill/>
+        </p:spPr>
+        <p:txBody>
+          <a:bodyPr wrap="square">
+            <a:spAutoFit/>
+          </a:bodyPr>
+          <a:lstStyle/>
+          <a:p>
+            <a:pPr>
+              <a:defRPr sz="1700" b="1">
+                <a:solidFill>
+                  <a:srgbClr val="0B2545"/>
+                </a:solidFill>
+              </a:defRPr>
+            </a:pPr>
+            <a:r>
+              <a:t>The two models are different but comparable in size.</a:t>
+            </a:r>
+          </a:p>
+        </p:txBody>
+      </p:sp>
+      <p:sp>
+        <p:nvSpPr>
+          <p:cNvPr id="4" name="Rectangle 3"/>
+          <p:cNvSpPr/>
+          <p:nvPr/>
+        </p:nvSpPr>
+        <p:spPr>
+          <a:xfrm>
+            <a:off x="256032" y="530352"/>
+            <a:ext cx="8458200" cy="18288"/>
+          </a:xfrm>
+          <a:prstGeom prst="rect">
+            <a:avLst/>
+          </a:prstGeom>
+          <a:solidFill>
+            <a:srgbClr val="1F4E79"/>
+          </a:solidFill>
+          <a:ln>
+            <a:solidFill>
+              <a:srgbClr val="1F4E79"/>
+            </a:solidFill>
+          </a:ln>
+        </p:spPr>
+        <p:style>
+          <a:lnRef idx="1">
+            <a:schemeClr val="accent1"/>
+          </a:lnRef>
+          <a:fillRef idx="3">
+            <a:schemeClr val="accent1"/>
+          </a:fillRef>
+          <a:effectRef idx="2">
+            <a:schemeClr val="accent1"/>
+          </a:effectRef>
+          <a:fontRef idx="minor">
+            <a:schemeClr val="lt1"/>
+          </a:fontRef>
+        </p:style>
+        <p:txBody>
+          <a:bodyPr rtlCol="0" anchor="ctr"/>
+          <a:lstStyle/>
+          <a:p>
+            <a:pPr algn="ctr"/>
+          </a:p>
+        </p:txBody>
+      </p:sp>
+      <p:sp>
+        <p:nvSpPr>
+          <p:cNvPr id="5" name="Rectangle 4"/>
+          <p:cNvSpPr/>
+          <p:nvPr/>
+        </p:nvSpPr>
+        <p:spPr>
+          <a:xfrm>
+            <a:off x="685800" y="1234440"/>
+            <a:ext cx="2240280" cy="1097280"/>
+          </a:xfrm>
+          <a:prstGeom prst="rect">
+            <a:avLst/>
+          </a:prstGeom>
+          <a:solidFill>
+            <a:srgbClr val="F2F4F7"/>
+          </a:solidFill>
+          <a:ln>
+            <a:solidFill>
+              <a:srgbClr val="D2D8E0"/>
+            </a:solidFill>
+          </a:ln>
+        </p:spPr>
+        <p:style>
+          <a:lnRef idx="1">
+            <a:schemeClr val="accent1"/>
+          </a:lnRef>
+          <a:fillRef idx="3">
+            <a:schemeClr val="accent1"/>
+          </a:fillRef>
+          <a:effectRef idx="2">
+            <a:schemeClr val="accent1"/>
+          </a:effectRef>
+          <a:fontRef idx="minor">
+            <a:schemeClr val="lt1"/>
+          </a:fontRef>
+        </p:style>
+        <p:txBody>
+          <a:bodyPr rtlCol="0" anchor="ctr"/>
+          <a:lstStyle/>
+          <a:p>
+            <a:pPr algn="ctr">
+              <a:defRPr sz="2400" b="1">
+                <a:solidFill>
+                  <a:srgbClr val="2E74B5"/>
+                </a:solidFill>
+              </a:defRPr>
+            </a:pPr>
+            <a:r>
+              <a:t>2.83M</a:t>
+            </a:r>
+          </a:p>
+          <a:p>
+            <a:pPr algn="ctr">
+              <a:defRPr sz="1100">
+                <a:solidFill>
+                  <a:srgbClr val="464646"/>
+                </a:solidFill>
+              </a:defRPr>
+            </a:pPr>
+            <a:r>
+              <a:t>LSTM parameters</a:t>
+            </a:r>
+          </a:p>
+        </p:txBody>
+      </p:sp>
+      <p:sp>
+        <p:nvSpPr>
+          <p:cNvPr id="6" name="Rectangle 5"/>
+          <p:cNvSpPr/>
+          <p:nvPr/>
+        </p:nvSpPr>
+        <p:spPr>
+          <a:xfrm>
+            <a:off x="3154680" y="1234440"/>
+            <a:ext cx="2240280" cy="1097280"/>
+          </a:xfrm>
+          <a:prstGeom prst="rect">
+            <a:avLst/>
+          </a:prstGeom>
+          <a:solidFill>
+            <a:srgbClr val="F2F4F7"/>
+          </a:solidFill>
+          <a:ln>
+            <a:solidFill>
+              <a:srgbClr val="D2D8E0"/>
+            </a:solidFill>
+          </a:ln>
+        </p:spPr>
+        <p:style>
+          <a:lnRef idx="1">
+            <a:schemeClr val="accent1"/>
+          </a:lnRef>
+          <a:fillRef idx="3">
+            <a:schemeClr val="accent1"/>
+          </a:fillRef>
+          <a:effectRef idx="2">
+            <a:schemeClr val="accent1"/>
+          </a:effectRef>
+          <a:fontRef idx="minor">
+            <a:schemeClr val="lt1"/>
+          </a:fontRef>
+        </p:style>
+        <p:txBody>
+          <a:bodyPr rtlCol="0" anchor="ctr"/>
+          <a:lstStyle/>
+          <a:p>
+            <a:pPr algn="ctr">
+              <a:defRPr sz="2400" b="1">
+                <a:solidFill>
+                  <a:srgbClr val="2E74B5"/>
+                </a:solidFill>
+              </a:defRPr>
+            </a:pPr>
+            <a:r>
+              <a:t>2.97M</a:t>
+            </a:r>
+          </a:p>
+          <a:p>
+            <a:pPr algn="ctr">
+              <a:defRPr sz="1100">
+                <a:solidFill>
+                  <a:srgbClr val="464646"/>
+                </a:solidFill>
+              </a:defRPr>
+            </a:pPr>
+            <a:r>
+              <a:t>Transformer parameters</a:t>
+            </a:r>
+          </a:p>
+        </p:txBody>
+      </p:sp>
+      <p:sp>
+        <p:nvSpPr>
+          <p:cNvPr id="7" name="TextBox 6"/>
+          <p:cNvSpPr txBox="1"/>
+          <p:nvPr/>
+        </p:nvSpPr>
+        <p:spPr>
+          <a:xfrm>
+            <a:off x="685800" y="2743200"/>
+            <a:ext cx="7772400" cy="3200400"/>
+          </a:xfrm>
+          <a:prstGeom prst="rect">
+            <a:avLst/>
+          </a:prstGeom>
+          <a:noFill/>
+        </p:spPr>
+        <p:txBody>
+          <a:bodyPr wrap="square">
+            <a:spAutoFit/>
+          </a:bodyPr>
+          <a:lstStyle/>
+          <a:p>
+            <a:pPr>
+              <a:spcAft>
+                <a:spcPts val="500"/>
+              </a:spcAft>
+              <a:defRPr sz="1150">
+                <a:solidFill>
+                  <a:srgbClr val="232323"/>
+                </a:solidFill>
+              </a:defRPr>
+            </a:pPr>
+            <a:r>
+              <a:t>LSTM: embedding layer, one-layer bidirectional LSTM, masked mean pooling, dropout, classifier.</a:t>
+            </a:r>
+          </a:p>
+          <a:p>
+            <a:pPr>
+              <a:spcAft>
+                <a:spcPts val="500"/>
+              </a:spcAft>
+              <a:defRPr sz="1150">
+                <a:solidFill>
+                  <a:srgbClr val="232323"/>
+                </a:solidFill>
+              </a:defRPr>
+            </a:pPr>
+            <a:r>
+              <a:t>Transformer Encoder: embeddings, learned positional encoding, two encoder layers, four heads, classifier.</a:t>
+            </a:r>
+          </a:p>
+          <a:p>
+            <a:pPr>
+              <a:spcAft>
+                <a:spcPts val="500"/>
+              </a:spcAft>
+              <a:defRPr sz="1150">
+                <a:solidFill>
+                  <a:srgbClr val="232323"/>
+                </a:solidFill>
+              </a:defRPr>
+            </a:pPr>
+            <a:r>
+              <a:t>Trainable parameters: LSTM 2.83M; Transformer Encoder 2.97M.</a:t>
+            </a:r>
+          </a:p>
+          <a:p>
+            <a:pPr>
+              <a:spcAft>
+                <a:spcPts val="500"/>
+              </a:spcAft>
+              <a:defRPr sz="1150">
+                <a:solidFill>
+                  <a:srgbClr val="232323"/>
+                </a:solidFill>
+              </a:defRPr>
+            </a:pPr>
+            <a:r>
+              <a:t>Both models are trained from scratch.</a:t>
+            </a:r>
+          </a:p>
+        </p:txBody>
+      </p:sp>
+      <p:sp>
+        <p:nvSpPr>
+          <p:cNvPr id="8" name="TextBox 7"/>
+          <p:cNvSpPr txBox="1"/>
+          <p:nvPr/>
+        </p:nvSpPr>
+        <p:spPr>
+          <a:xfrm>
+            <a:off x="109728" y="6565392"/>
+            <a:ext cx="3200400" cy="146304"/>
           </a:xfrm>
           <a:prstGeom prst="rect">
             <a:avLst/>
@@ -4726,120 +5446,28 @@
           <a:lstStyle/>
           <a:p>
             <a:pPr>
-              <a:defRPr sz="2800" b="1">
-                <a:solidFill>
-                  <a:srgbClr val="0B2545"/>
-                </a:solidFill>
-              </a:defRPr>
-            </a:pPr>
-            <a:r>
-              <a:t>Both models show overfitting by epoch 6.</a:t>
-            </a:r>
-          </a:p>
-        </p:txBody>
-      </p:sp>
-      <p:pic>
-        <p:nvPicPr>
-          <p:cNvPr id="4" name="Picture 3" descr="lstm_confusion_matrix.png"/>
-          <p:cNvPicPr>
-            <a:picLocks noChangeAspect="1"/>
-          </p:cNvPicPr>
-          <p:nvPr/>
-        </p:nvPicPr>
-        <p:blipFill>
-          <a:blip r:embed="rId2"/>
-          <a:stretch>
-            <a:fillRect/>
-          </a:stretch>
-        </p:blipFill>
-        <p:spPr>
-          <a:xfrm>
-            <a:off x="6217920" y="1508760"/>
-            <a:ext cx="4983480" cy="4152900"/>
-          </a:xfrm>
-          <a:prstGeom prst="rect">
-            <a:avLst/>
-          </a:prstGeom>
-        </p:spPr>
-      </p:pic>
-      <p:sp>
-        <p:nvSpPr>
-          <p:cNvPr id="5" name="TextBox 4"/>
+              <a:defRPr sz="550">
+                <a:solidFill>
+                  <a:srgbClr val="1F4E79"/>
+                </a:solidFill>
+              </a:defRPr>
+            </a:pPr>
+            <a:r>
+              <a:t>Advanced Battery Manufacturing Systems</a:t>
+            </a:r>
+          </a:p>
+        </p:txBody>
+      </p:sp>
+      <p:sp>
+        <p:nvSpPr>
+          <p:cNvPr id="9" name="TextBox 8"/>
           <p:cNvSpPr txBox="1"/>
           <p:nvPr/>
         </p:nvSpPr>
         <p:spPr>
           <a:xfrm>
-            <a:off x="685800" y="1600200"/>
-            <a:ext cx="5120640" cy="4297680"/>
-          </a:xfrm>
-          <a:prstGeom prst="rect">
-            <a:avLst/>
-          </a:prstGeom>
-          <a:noFill/>
-        </p:spPr>
-        <p:txBody>
-          <a:bodyPr wrap="square">
-            <a:spAutoFit/>
-          </a:bodyPr>
-          <a:lstStyle/>
-          <a:p>
-            <a:pPr>
-              <a:spcAft>
-                <a:spcPts val="800"/>
-              </a:spcAft>
-              <a:defRPr sz="1700">
-                <a:solidFill>
-                  <a:srgbClr val="232323"/>
-                </a:solidFill>
-              </a:defRPr>
-            </a:pPr>
-            <a:r>
-              <a:t>Training loss continues falling.</a:t>
-            </a:r>
-          </a:p>
-          <a:p>
-            <a:pPr>
-              <a:spcAft>
-                <a:spcPts val="800"/>
-              </a:spcAft>
-              <a:defRPr sz="1700">
-                <a:solidFill>
-                  <a:srgbClr val="232323"/>
-                </a:solidFill>
-              </a:defRPr>
-            </a:pPr>
-            <a:r>
-              <a:t>Validation loss rises late in training.</a:t>
-            </a:r>
-          </a:p>
-          <a:p>
-            <a:pPr>
-              <a:spcAft>
-                <a:spcPts val="800"/>
-              </a:spcAft>
-              <a:defRPr sz="1700">
-                <a:solidFill>
-                  <a:srgbClr val="232323"/>
-                </a:solidFill>
-              </a:defRPr>
-            </a:pPr>
-            <a:r>
-              <a:t>Early stopping or stronger regularization is the most direct next experiment.</a:t>
-            </a:r>
-          </a:p>
-        </p:txBody>
-      </p:sp>
-      <p:sp>
-        <p:nvSpPr>
-          <p:cNvPr id="6" name="TextBox 5"/>
-          <p:cNvSpPr txBox="1"/>
-          <p:nvPr/>
-        </p:nvSpPr>
-        <p:spPr>
-          <a:xfrm>
-            <a:off x="10881360" y="6355080"/>
-            <a:ext cx="640080" cy="182880"/>
+            <a:off x="8412480" y="6565392"/>
+            <a:ext cx="502920" cy="146304"/>
           </a:xfrm>
           <a:prstGeom prst="rect">
             <a:avLst/>
@@ -4853,14 +5481,14 @@
           <a:lstStyle/>
           <a:p>
             <a:pPr algn="r">
-              <a:defRPr sz="800">
+              <a:defRPr sz="550">
                 <a:solidFill>
                   <a:srgbClr val="787878"/>
                 </a:solidFill>
               </a:defRPr>
             </a:pPr>
             <a:r>
-              <a:t>6</a:t>
+              <a:t>6 of 11</a:t>
             </a:r>
           </a:p>
         </p:txBody>
@@ -4879,7 +5507,7 @@
     <p:bg>
       <p:bgPr>
         <a:solidFill>
-          <a:srgbClr val="FAFAF8"/>
+          <a:srgbClr val="FFFFFF"/>
         </a:solidFill>
         <a:effectLst/>
       </p:bgPr>
@@ -4891,79 +5519,9 @@
         <p:nvPr/>
       </p:nvGrpSpPr>
       <p:grpSpPr/>
-      <p:sp>
-        <p:nvSpPr>
-          <p:cNvPr id="2" name="TextBox 1"/>
-          <p:cNvSpPr txBox="1"/>
-          <p:nvPr/>
-        </p:nvSpPr>
-        <p:spPr>
-          <a:xfrm>
-            <a:off x="502920" y="320040"/>
-            <a:ext cx="10789920" cy="320040"/>
-          </a:xfrm>
-          <a:prstGeom prst="rect">
-            <a:avLst/>
-          </a:prstGeom>
-          <a:noFill/>
-        </p:spPr>
-        <p:txBody>
-          <a:bodyPr wrap="none">
-            <a:spAutoFit/>
-          </a:bodyPr>
-          <a:lstStyle/>
-          <a:p>
-            <a:pPr>
-              <a:defRPr sz="1000" b="1">
-                <a:solidFill>
-                  <a:srgbClr val="366092"/>
-                </a:solidFill>
-              </a:defRPr>
-            </a:pPr>
-            <a:r>
-              <a:t>CLASS-LEVEL ERRORS</a:t>
-            </a:r>
-          </a:p>
-        </p:txBody>
-      </p:sp>
-      <p:sp>
-        <p:nvSpPr>
-          <p:cNvPr id="3" name="TextBox 2"/>
-          <p:cNvSpPr txBox="1"/>
-          <p:nvPr/>
-        </p:nvSpPr>
-        <p:spPr>
-          <a:xfrm>
-            <a:off x="502920" y="658368"/>
-            <a:ext cx="10789920" cy="731520"/>
-          </a:xfrm>
-          <a:prstGeom prst="rect">
-            <a:avLst/>
-          </a:prstGeom>
-          <a:noFill/>
-        </p:spPr>
-        <p:txBody>
-          <a:bodyPr wrap="none">
-            <a:spAutoFit/>
-          </a:bodyPr>
-          <a:lstStyle/>
-          <a:p>
-            <a:pPr>
-              <a:defRPr sz="2800" b="1">
-                <a:solidFill>
-                  <a:srgbClr val="0B2545"/>
-                </a:solidFill>
-              </a:defRPr>
-            </a:pPr>
-            <a:r>
-              <a:t>Business and Sci/Tech are the main confusion pair.</a:t>
-            </a:r>
-          </a:p>
-        </p:txBody>
-      </p:sp>
       <p:pic>
         <p:nvPicPr>
-          <p:cNvPr id="4" name="Picture 3" descr="transformer_confusion_matrix.png"/>
+          <p:cNvPr id="2" name="Picture 1" descr="main_loss_curves.png"/>
           <p:cNvPicPr>
             <a:picLocks noChangeAspect="1"/>
           </p:cNvPicPr>
@@ -4977,8 +5535,8 @@
         </p:blipFill>
         <p:spPr>
           <a:xfrm>
-            <a:off x="6217920" y="1508760"/>
-            <a:ext cx="4983480" cy="4152900"/>
+            <a:off x="4892040" y="914400"/>
+            <a:ext cx="3794760" cy="2371725"/>
           </a:xfrm>
           <a:prstGeom prst="rect">
             <a:avLst/>
@@ -4987,14 +5545,49 @@
       </p:pic>
       <p:sp>
         <p:nvSpPr>
-          <p:cNvPr id="5" name="TextBox 4"/>
+          <p:cNvPr id="3" name="TextBox 2"/>
           <p:cNvSpPr txBox="1"/>
           <p:nvPr/>
         </p:nvSpPr>
         <p:spPr>
           <a:xfrm>
-            <a:off x="685800" y="1600200"/>
-            <a:ext cx="5120640" cy="4297680"/>
+            <a:off x="73152" y="109728"/>
+            <a:ext cx="228600" cy="201168"/>
+          </a:xfrm>
+          <a:prstGeom prst="rect">
+            <a:avLst/>
+          </a:prstGeom>
+          <a:noFill/>
+        </p:spPr>
+        <p:txBody>
+          <a:bodyPr wrap="none">
+            <a:spAutoFit/>
+          </a:bodyPr>
+          <a:lstStyle/>
+          <a:p>
+            <a:pPr>
+              <a:defRPr sz="1300" b="1">
+                <a:solidFill>
+                  <a:srgbClr val="1F4E79"/>
+                </a:solidFill>
+              </a:defRPr>
+            </a:pPr>
+            <a:r>
+              <a:t>7</a:t>
+            </a:r>
+          </a:p>
+        </p:txBody>
+      </p:sp>
+      <p:sp>
+        <p:nvSpPr>
+          <p:cNvPr id="4" name="TextBox 3"/>
+          <p:cNvSpPr txBox="1"/>
+          <p:nvPr/>
+        </p:nvSpPr>
+        <p:spPr>
+          <a:xfrm>
+            <a:off x="256032" y="146304"/>
+            <a:ext cx="8458200" cy="384048"/>
           </a:xfrm>
           <a:prstGeom prst="rect">
             <a:avLst/>
@@ -5008,48 +5601,60 @@
           <a:lstStyle/>
           <a:p>
             <a:pPr>
-              <a:spcAft>
-                <a:spcPts val="800"/>
-              </a:spcAft>
-              <a:defRPr sz="1700">
-                <a:solidFill>
-                  <a:srgbClr val="232323"/>
-                </a:solidFill>
-              </a:defRPr>
-            </a:pPr>
-            <a:r>
-              <a:t>Sports is easiest for both models.</a:t>
-            </a:r>
-          </a:p>
-          <a:p>
-            <a:pPr>
-              <a:spcAft>
-                <a:spcPts val="800"/>
-              </a:spcAft>
-              <a:defRPr sz="1700">
-                <a:solidFill>
-                  <a:srgbClr val="232323"/>
-                </a:solidFill>
-              </a:defRPr>
-            </a:pPr>
-            <a:r>
-              <a:t>Business/Sci-Tech stories often mix company, market, and technology cues.</a:t>
-            </a:r>
-          </a:p>
-          <a:p>
-            <a:pPr>
-              <a:spcAft>
-                <a:spcPts val="800"/>
-              </a:spcAft>
-              <a:defRPr sz="1700">
-                <a:solidFill>
-                  <a:srgbClr val="232323"/>
-                </a:solidFill>
-              </a:defRPr>
-            </a:pPr>
-            <a:r>
-              <a:t>Confusion matrices support the failure-analysis examples.</a:t>
-            </a:r>
+              <a:defRPr sz="1700" b="1">
+                <a:solidFill>
+                  <a:srgbClr val="0B2545"/>
+                </a:solidFill>
+              </a:defRPr>
+            </a:pPr>
+            <a:r>
+              <a:t>Both models perform similarly, with a slight Transformer Encoder advantage.</a:t>
+            </a:r>
+          </a:p>
+        </p:txBody>
+      </p:sp>
+      <p:sp>
+        <p:nvSpPr>
+          <p:cNvPr id="5" name="Rectangle 4"/>
+          <p:cNvSpPr/>
+          <p:nvPr/>
+        </p:nvSpPr>
+        <p:spPr>
+          <a:xfrm>
+            <a:off x="256032" y="530352"/>
+            <a:ext cx="8458200" cy="18288"/>
+          </a:xfrm>
+          <a:prstGeom prst="rect">
+            <a:avLst/>
+          </a:prstGeom>
+          <a:solidFill>
+            <a:srgbClr val="1F4E79"/>
+          </a:solidFill>
+          <a:ln>
+            <a:solidFill>
+              <a:srgbClr val="1F4E79"/>
+            </a:solidFill>
+          </a:ln>
+        </p:spPr>
+        <p:style>
+          <a:lnRef idx="1">
+            <a:schemeClr val="accent1"/>
+          </a:lnRef>
+          <a:fillRef idx="3">
+            <a:schemeClr val="accent1"/>
+          </a:fillRef>
+          <a:effectRef idx="2">
+            <a:schemeClr val="accent1"/>
+          </a:effectRef>
+          <a:fontRef idx="minor">
+            <a:schemeClr val="lt1"/>
+          </a:fontRef>
+        </p:style>
+        <p:txBody>
+          <a:bodyPr rtlCol="0" anchor="ctr"/>
+          <a:lstStyle/>
+          <a:p>
+            <a:pPr algn="ctr"/>
           </a:p>
         </p:txBody>
       </p:sp>
@@ -5061,8 +5666,76 @@
         </p:nvSpPr>
         <p:spPr>
           <a:xfrm>
-            <a:off x="10881360" y="6355080"/>
-            <a:ext cx="640080" cy="182880"/>
+            <a:off x="502920" y="960120"/>
+            <a:ext cx="4160520" cy="5120640"/>
+          </a:xfrm>
+          <a:prstGeom prst="rect">
+            <a:avLst/>
+          </a:prstGeom>
+          <a:noFill/>
+        </p:spPr>
+        <p:txBody>
+          <a:bodyPr wrap="square">
+            <a:spAutoFit/>
+          </a:bodyPr>
+          <a:lstStyle/>
+          <a:p>
+            <a:pPr>
+              <a:spcAft>
+                <a:spcPts val="500"/>
+              </a:spcAft>
+              <a:defRPr sz="1100">
+                <a:solidFill>
+                  <a:srgbClr val="232323"/>
+                </a:solidFill>
+              </a:defRPr>
+            </a:pPr>
+            <a:r>
+              <a:t>LSTM test accuracy: 0.9120; macro F1: 0.9118.</a:t>
+            </a:r>
+          </a:p>
+          <a:p>
+            <a:pPr>
+              <a:spcAft>
+                <a:spcPts val="500"/>
+              </a:spcAft>
+              <a:defRPr sz="1100">
+                <a:solidFill>
+                  <a:srgbClr val="232323"/>
+                </a:solidFill>
+              </a:defRPr>
+            </a:pPr>
+            <a:r>
+              <a:t>Transformer Encoder test accuracy: 0.9125; macro F1: 0.9126.</a:t>
+            </a:r>
+          </a:p>
+          <a:p>
+            <a:pPr>
+              <a:spcAft>
+                <a:spcPts val="500"/>
+              </a:spcAft>
+              <a:defRPr sz="1100">
+                <a:solidFill>
+                  <a:srgbClr val="232323"/>
+                </a:solidFill>
+              </a:defRPr>
+            </a:pPr>
+            <a:r>
+              <a:t>The difference is small, so the conclusion should be cautious.</a:t>
+            </a:r>
+          </a:p>
+        </p:txBody>
+      </p:sp>
+      <p:sp>
+        <p:nvSpPr>
+          <p:cNvPr id="7" name="TextBox 6"/>
+          <p:cNvSpPr txBox="1"/>
+          <p:nvPr/>
+        </p:nvSpPr>
+        <p:spPr>
+          <a:xfrm>
+            <a:off x="109728" y="6565392"/>
+            <a:ext cx="3200400" cy="146304"/>
           </a:xfrm>
           <a:prstGeom prst="rect">
             <a:avLst/>
@@ -5075,15 +5748,50 @@
           </a:bodyPr>
           <a:lstStyle/>
           <a:p>
+            <a:pPr>
+              <a:defRPr sz="550">
+                <a:solidFill>
+                  <a:srgbClr val="1F4E79"/>
+                </a:solidFill>
+              </a:defRPr>
+            </a:pPr>
+            <a:r>
+              <a:t>Advanced Battery Manufacturing Systems</a:t>
+            </a:r>
+          </a:p>
+        </p:txBody>
+      </p:sp>
+      <p:sp>
+        <p:nvSpPr>
+          <p:cNvPr id="8" name="TextBox 7"/>
+          <p:cNvSpPr txBox="1"/>
+          <p:nvPr/>
+        </p:nvSpPr>
+        <p:spPr>
+          <a:xfrm>
+            <a:off x="8412480" y="6565392"/>
+            <a:ext cx="502920" cy="146304"/>
+          </a:xfrm>
+          <a:prstGeom prst="rect">
+            <a:avLst/>
+          </a:prstGeom>
+          <a:noFill/>
+        </p:spPr>
+        <p:txBody>
+          <a:bodyPr wrap="none">
+            <a:spAutoFit/>
+          </a:bodyPr>
+          <a:lstStyle/>
+          <a:p>
             <a:pPr algn="r">
-              <a:defRPr sz="800">
+              <a:defRPr sz="550">
                 <a:solidFill>
                   <a:srgbClr val="787878"/>
                 </a:solidFill>
               </a:defRPr>
             </a:pPr>
             <a:r>
-              <a:t>7</a:t>
+              <a:t>7 of 11</a:t>
             </a:r>
           </a:p>
         </p:txBody>
@@ -5102,7 +5810,7 @@
     <p:bg>
       <p:bgPr>
         <a:solidFill>
-          <a:srgbClr val="FAFAF8"/>
+          <a:srgbClr val="FFFFFF"/>
         </a:solidFill>
         <a:effectLst/>
       </p:bgPr>
@@ -5114,16 +5822,40 @@
         <p:nvPr/>
       </p:nvGrpSpPr>
       <p:grpSpPr/>
-      <p:sp>
-        <p:nvSpPr>
-          <p:cNvPr id="2" name="TextBox 1"/>
+      <p:pic>
+        <p:nvPicPr>
+          <p:cNvPr id="2" name="Picture 1" descr="main_loss_curves.png"/>
+          <p:cNvPicPr>
+            <a:picLocks noChangeAspect="1"/>
+          </p:cNvPicPr>
+          <p:nvPr/>
+        </p:nvPicPr>
+        <p:blipFill>
+          <a:blip r:embed="rId2"/>
+          <a:stretch>
+            <a:fillRect/>
+          </a:stretch>
+        </p:blipFill>
+        <p:spPr>
+          <a:xfrm>
+            <a:off x="4892040" y="914400"/>
+            <a:ext cx="3794760" cy="2371725"/>
+          </a:xfrm>
+          <a:prstGeom prst="rect">
+            <a:avLst/>
+          </a:prstGeom>
+        </p:spPr>
+      </p:pic>
+      <p:sp>
+        <p:nvSpPr>
+          <p:cNvPr id="3" name="TextBox 2"/>
           <p:cNvSpPr txBox="1"/>
           <p:nvPr/>
         </p:nvSpPr>
         <p:spPr>
           <a:xfrm>
-            <a:off x="502920" y="320040"/>
-            <a:ext cx="10789920" cy="320040"/>
+            <a:off x="73152" y="109728"/>
+            <a:ext cx="228600" cy="201168"/>
           </a:xfrm>
           <a:prstGeom prst="rect">
             <a:avLst/>
@@ -5137,28 +5869,176 @@
           <a:lstStyle/>
           <a:p>
             <a:pPr>
-              <a:defRPr sz="1000" b="1">
-                <a:solidFill>
-                  <a:srgbClr val="366092"/>
-                </a:solidFill>
-              </a:defRPr>
-            </a:pPr>
-            <a:r>
-              <a:t>DATASET-SIZE ABLATION</a:t>
-            </a:r>
-          </a:p>
-        </p:txBody>
-      </p:sp>
-      <p:sp>
-        <p:nvSpPr>
-          <p:cNvPr id="3" name="TextBox 2"/>
+              <a:defRPr sz="1300" b="1">
+                <a:solidFill>
+                  <a:srgbClr val="1F4E79"/>
+                </a:solidFill>
+              </a:defRPr>
+            </a:pPr>
+            <a:r>
+              <a:t>8</a:t>
+            </a:r>
+          </a:p>
+        </p:txBody>
+      </p:sp>
+      <p:sp>
+        <p:nvSpPr>
+          <p:cNvPr id="4" name="TextBox 3"/>
           <p:cNvSpPr txBox="1"/>
           <p:nvPr/>
         </p:nvSpPr>
         <p:spPr>
           <a:xfrm>
-            <a:off x="502920" y="658368"/>
-            <a:ext cx="10789920" cy="731520"/>
+            <a:off x="256032" y="146304"/>
+            <a:ext cx="8458200" cy="384048"/>
+          </a:xfrm>
+          <a:prstGeom prst="rect">
+            <a:avLst/>
+          </a:prstGeom>
+          <a:noFill/>
+        </p:spPr>
+        <p:txBody>
+          <a:bodyPr wrap="square">
+            <a:spAutoFit/>
+          </a:bodyPr>
+          <a:lstStyle/>
+          <a:p>
+            <a:pPr>
+              <a:defRPr sz="1700" b="1">
+                <a:solidFill>
+                  <a:srgbClr val="0B2545"/>
+                </a:solidFill>
+              </a:defRPr>
+            </a:pPr>
+            <a:r>
+              <a:t>Both models show overfitting by the final epoch.</a:t>
+            </a:r>
+          </a:p>
+        </p:txBody>
+      </p:sp>
+      <p:sp>
+        <p:nvSpPr>
+          <p:cNvPr id="5" name="Rectangle 4"/>
+          <p:cNvSpPr/>
+          <p:nvPr/>
+        </p:nvSpPr>
+        <p:spPr>
+          <a:xfrm>
+            <a:off x="256032" y="530352"/>
+            <a:ext cx="8458200" cy="18288"/>
+          </a:xfrm>
+          <a:prstGeom prst="rect">
+            <a:avLst/>
+          </a:prstGeom>
+          <a:solidFill>
+            <a:srgbClr val="1F4E79"/>
+          </a:solidFill>
+          <a:ln>
+            <a:solidFill>
+              <a:srgbClr val="1F4E79"/>
+            </a:solidFill>
+          </a:ln>
+        </p:spPr>
+        <p:style>
+          <a:lnRef idx="1">
+            <a:schemeClr val="accent1"/>
+          </a:lnRef>
+          <a:fillRef idx="3">
+            <a:schemeClr val="accent1"/>
+          </a:fillRef>
+          <a:effectRef idx="2">
+            <a:schemeClr val="accent1"/>
+          </a:effectRef>
+          <a:fontRef idx="minor">
+            <a:schemeClr val="lt1"/>
+          </a:fontRef>
+        </p:style>
+        <p:txBody>
+          <a:bodyPr rtlCol="0" anchor="ctr"/>
+          <a:lstStyle/>
+          <a:p>
+            <a:pPr algn="ctr"/>
+          </a:p>
+        </p:txBody>
+      </p:sp>
+      <p:sp>
+        <p:nvSpPr>
+          <p:cNvPr id="6" name="TextBox 5"/>
+          <p:cNvSpPr txBox="1"/>
+          <p:nvPr/>
+        </p:nvSpPr>
+        <p:spPr>
+          <a:xfrm>
+            <a:off x="502920" y="960120"/>
+            <a:ext cx="4160520" cy="5120640"/>
+          </a:xfrm>
+          <a:prstGeom prst="rect">
+            <a:avLst/>
+          </a:prstGeom>
+          <a:noFill/>
+        </p:spPr>
+        <p:txBody>
+          <a:bodyPr wrap="square">
+            <a:spAutoFit/>
+          </a:bodyPr>
+          <a:lstStyle/>
+          <a:p>
+            <a:pPr>
+              <a:spcAft>
+                <a:spcPts val="500"/>
+              </a:spcAft>
+              <a:defRPr sz="1100">
+                <a:solidFill>
+                  <a:srgbClr val="232323"/>
+                </a:solidFill>
+              </a:defRPr>
+            </a:pPr>
+            <a:r>
+              <a:t>Training loss continues to decrease across 6 epochs.</a:t>
+            </a:r>
+          </a:p>
+          <a:p>
+            <a:pPr>
+              <a:spcAft>
+                <a:spcPts val="500"/>
+              </a:spcAft>
+              <a:defRPr sz="1100">
+                <a:solidFill>
+                  <a:srgbClr val="232323"/>
+                </a:solidFill>
+              </a:defRPr>
+            </a:pPr>
+            <a:r>
+              <a:t>Validation loss rises late in training.</a:t>
+            </a:r>
+          </a:p>
+          <a:p>
+            <a:pPr>
+              <a:spcAft>
+                <a:spcPts val="500"/>
+              </a:spcAft>
+              <a:defRPr sz="1100">
+                <a:solidFill>
+                  <a:srgbClr val="232323"/>
+                </a:solidFill>
+              </a:defRPr>
+            </a:pPr>
+            <a:r>
+              <a:t>This suggests early stopping or stronger regularization as the next experiment.</a:t>
+            </a:r>
+          </a:p>
+        </p:txBody>
+      </p:sp>
+      <p:sp>
+        <p:nvSpPr>
+          <p:cNvPr id="7" name="TextBox 6"/>
+          <p:cNvSpPr txBox="1"/>
+          <p:nvPr/>
+        </p:nvSpPr>
+        <p:spPr>
+          <a:xfrm>
+            <a:off x="109728" y="6565392"/>
+            <a:ext cx="3200400" cy="146304"/>
           </a:xfrm>
           <a:prstGeom prst="rect">
             <a:avLst/>
@@ -5172,96 +6052,28 @@
           <a:lstStyle/>
           <a:p>
             <a:pPr>
-              <a:defRPr sz="2800" b="1">
-                <a:solidFill>
-                  <a:srgbClr val="0B2545"/>
-                </a:solidFill>
-              </a:defRPr>
-            </a:pPr>
-            <a:r>
-              <a:t>LSTM is stronger with less data; Transformer benefits from full data.</a:t>
-            </a:r>
-          </a:p>
-        </p:txBody>
-      </p:sp>
-      <p:sp>
-        <p:nvSpPr>
-          <p:cNvPr id="4" name="TextBox 3"/>
+              <a:defRPr sz="550">
+                <a:solidFill>
+                  <a:srgbClr val="1F4E79"/>
+                </a:solidFill>
+              </a:defRPr>
+            </a:pPr>
+            <a:r>
+              <a:t>Advanced Battery Manufacturing Systems</a:t>
+            </a:r>
+          </a:p>
+        </p:txBody>
+      </p:sp>
+      <p:sp>
+        <p:nvSpPr>
+          <p:cNvPr id="8" name="TextBox 7"/>
           <p:cNvSpPr txBox="1"/>
           <p:nvPr/>
         </p:nvSpPr>
         <p:spPr>
           <a:xfrm>
-            <a:off x="822960" y="1691640"/>
-            <a:ext cx="10241280" cy="4389120"/>
-          </a:xfrm>
-          <a:prstGeom prst="rect">
-            <a:avLst/>
-          </a:prstGeom>
-          <a:noFill/>
-        </p:spPr>
-        <p:txBody>
-          <a:bodyPr wrap="square">
-            <a:spAutoFit/>
-          </a:bodyPr>
-          <a:lstStyle/>
-          <a:p>
-            <a:pPr>
-              <a:spcAft>
-                <a:spcPts val="800"/>
-              </a:spcAft>
-              <a:defRPr sz="2000">
-                <a:solidFill>
-                  <a:srgbClr val="232323"/>
-                </a:solidFill>
-              </a:defRPr>
-            </a:pPr>
-            <a:r>
-              <a:t>25% data: LSTM 0.8719 vs Transformer 0.8699 validation accuracy.</a:t>
-            </a:r>
-          </a:p>
-          <a:p>
-            <a:pPr>
-              <a:spcAft>
-                <a:spcPts val="800"/>
-              </a:spcAft>
-              <a:defRPr sz="2000">
-                <a:solidFill>
-                  <a:srgbClr val="232323"/>
-                </a:solidFill>
-              </a:defRPr>
-            </a:pPr>
-            <a:r>
-              <a:t>50% data: LSTM 0.8944 vs Transformer 0.8901.</a:t>
-            </a:r>
-          </a:p>
-          <a:p>
-            <a:pPr>
-              <a:spcAft>
-                <a:spcPts val="800"/>
-              </a:spcAft>
-              <a:defRPr sz="2000">
-                <a:solidFill>
-                  <a:srgbClr val="232323"/>
-                </a:solidFill>
-              </a:defRPr>
-            </a:pPr>
-            <a:r>
-              <a:t>100% data: Transformer 0.9146 vs LSTM 0.9089.</a:t>
-            </a:r>
-          </a:p>
-        </p:txBody>
-      </p:sp>
-      <p:sp>
-        <p:nvSpPr>
-          <p:cNvPr id="5" name="TextBox 4"/>
-          <p:cNvSpPr txBox="1"/>
-          <p:nvPr/>
-        </p:nvSpPr>
-        <p:spPr>
-          <a:xfrm>
-            <a:off x="10881360" y="6355080"/>
-            <a:ext cx="640080" cy="182880"/>
+            <a:off x="8412480" y="6565392"/>
+            <a:ext cx="502920" cy="146304"/>
           </a:xfrm>
           <a:prstGeom prst="rect">
             <a:avLst/>
@@ -5275,14 +6087,14 @@
           <a:lstStyle/>
           <a:p>
             <a:pPr algn="r">
-              <a:defRPr sz="800">
+              <a:defRPr sz="550">
                 <a:solidFill>
                   <a:srgbClr val="787878"/>
                 </a:solidFill>
               </a:defRPr>
             </a:pPr>
             <a:r>
-              <a:t>8</a:t>
+              <a:t>8 of 11</a:t>
             </a:r>
           </a:p>
         </p:txBody>
@@ -5301,7 +6113,7 @@
     <p:bg>
       <p:bgPr>
         <a:solidFill>
-          <a:srgbClr val="FAFAF8"/>
+          <a:srgbClr val="FFFFFF"/>
         </a:solidFill>
         <a:effectLst/>
       </p:bgPr>
@@ -5313,16 +6125,40 @@
         <p:nvPr/>
       </p:nvGrpSpPr>
       <p:grpSpPr/>
-      <p:sp>
-        <p:nvSpPr>
-          <p:cNvPr id="2" name="TextBox 1"/>
+      <p:pic>
+        <p:nvPicPr>
+          <p:cNvPr id="2" name="Picture 1" descr="transformer_confusion_matrix.png"/>
+          <p:cNvPicPr>
+            <a:picLocks noChangeAspect="1"/>
+          </p:cNvPicPr>
+          <p:nvPr/>
+        </p:nvPicPr>
+        <p:blipFill>
+          <a:blip r:embed="rId2"/>
+          <a:stretch>
+            <a:fillRect/>
+          </a:stretch>
+        </p:blipFill>
+        <p:spPr>
+          <a:xfrm>
+            <a:off x="4892040" y="914400"/>
+            <a:ext cx="3794760" cy="3162300"/>
+          </a:xfrm>
+          <a:prstGeom prst="rect">
+            <a:avLst/>
+          </a:prstGeom>
+        </p:spPr>
+      </p:pic>
+      <p:sp>
+        <p:nvSpPr>
+          <p:cNvPr id="3" name="TextBox 2"/>
           <p:cNvSpPr txBox="1"/>
           <p:nvPr/>
         </p:nvSpPr>
         <p:spPr>
           <a:xfrm>
-            <a:off x="502920" y="320040"/>
-            <a:ext cx="10789920" cy="320040"/>
+            <a:off x="73152" y="109728"/>
+            <a:ext cx="228600" cy="201168"/>
           </a:xfrm>
           <a:prstGeom prst="rect">
             <a:avLst/>
@@ -5336,28 +6172,176 @@
           <a:lstStyle/>
           <a:p>
             <a:pPr>
-              <a:defRPr sz="1000" b="1">
-                <a:solidFill>
-                  <a:srgbClr val="366092"/>
-                </a:solidFill>
-              </a:defRPr>
-            </a:pPr>
-            <a:r>
-              <a:t>SEQUENCE LENGTH AND FAILURES</a:t>
-            </a:r>
-          </a:p>
-        </p:txBody>
-      </p:sp>
-      <p:sp>
-        <p:nvSpPr>
-          <p:cNvPr id="3" name="TextBox 2"/>
+              <a:defRPr sz="1300" b="1">
+                <a:solidFill>
+                  <a:srgbClr val="1F4E79"/>
+                </a:solidFill>
+              </a:defRPr>
+            </a:pPr>
+            <a:r>
+              <a:t>9</a:t>
+            </a:r>
+          </a:p>
+        </p:txBody>
+      </p:sp>
+      <p:sp>
+        <p:nvSpPr>
+          <p:cNvPr id="4" name="TextBox 3"/>
           <p:cNvSpPr txBox="1"/>
           <p:nvPr/>
         </p:nvSpPr>
         <p:spPr>
           <a:xfrm>
-            <a:off x="502920" y="658368"/>
-            <a:ext cx="10789920" cy="731520"/>
+            <a:off x="256032" y="146304"/>
+            <a:ext cx="8458200" cy="384048"/>
+          </a:xfrm>
+          <a:prstGeom prst="rect">
+            <a:avLst/>
+          </a:prstGeom>
+          <a:noFill/>
+        </p:spPr>
+        <p:txBody>
+          <a:bodyPr wrap="square">
+            <a:spAutoFit/>
+          </a:bodyPr>
+          <a:lstStyle/>
+          <a:p>
+            <a:pPr>
+              <a:defRPr sz="1700" b="1">
+                <a:solidFill>
+                  <a:srgbClr val="0B2545"/>
+                </a:solidFill>
+              </a:defRPr>
+            </a:pPr>
+            <a:r>
+              <a:t>Business and Sci/Tech are the main source of class-level errors.</a:t>
+            </a:r>
+          </a:p>
+        </p:txBody>
+      </p:sp>
+      <p:sp>
+        <p:nvSpPr>
+          <p:cNvPr id="5" name="Rectangle 4"/>
+          <p:cNvSpPr/>
+          <p:nvPr/>
+        </p:nvSpPr>
+        <p:spPr>
+          <a:xfrm>
+            <a:off x="256032" y="530352"/>
+            <a:ext cx="8458200" cy="18288"/>
+          </a:xfrm>
+          <a:prstGeom prst="rect">
+            <a:avLst/>
+          </a:prstGeom>
+          <a:solidFill>
+            <a:srgbClr val="1F4E79"/>
+          </a:solidFill>
+          <a:ln>
+            <a:solidFill>
+              <a:srgbClr val="1F4E79"/>
+            </a:solidFill>
+          </a:ln>
+        </p:spPr>
+        <p:style>
+          <a:lnRef idx="1">
+            <a:schemeClr val="accent1"/>
+          </a:lnRef>
+          <a:fillRef idx="3">
+            <a:schemeClr val="accent1"/>
+          </a:fillRef>
+          <a:effectRef idx="2">
+            <a:schemeClr val="accent1"/>
+          </a:effectRef>
+          <a:fontRef idx="minor">
+            <a:schemeClr val="lt1"/>
+          </a:fontRef>
+        </p:style>
+        <p:txBody>
+          <a:bodyPr rtlCol="0" anchor="ctr"/>
+          <a:lstStyle/>
+          <a:p>
+            <a:pPr algn="ctr"/>
+          </a:p>
+        </p:txBody>
+      </p:sp>
+      <p:sp>
+        <p:nvSpPr>
+          <p:cNvPr id="6" name="TextBox 5"/>
+          <p:cNvSpPr txBox="1"/>
+          <p:nvPr/>
+        </p:nvSpPr>
+        <p:spPr>
+          <a:xfrm>
+            <a:off x="502920" y="960120"/>
+            <a:ext cx="4160520" cy="5120640"/>
+          </a:xfrm>
+          <a:prstGeom prst="rect">
+            <a:avLst/>
+          </a:prstGeom>
+          <a:noFill/>
+        </p:spPr>
+        <p:txBody>
+          <a:bodyPr wrap="square">
+            <a:spAutoFit/>
+          </a:bodyPr>
+          <a:lstStyle/>
+          <a:p>
+            <a:pPr>
+              <a:spcAft>
+                <a:spcPts val="500"/>
+              </a:spcAft>
+              <a:defRPr sz="1100">
+                <a:solidFill>
+                  <a:srgbClr val="232323"/>
+                </a:solidFill>
+              </a:defRPr>
+            </a:pPr>
+            <a:r>
+              <a:t>Sports is the easiest class for both models.</a:t>
+            </a:r>
+          </a:p>
+          <a:p>
+            <a:pPr>
+              <a:spcAft>
+                <a:spcPts val="500"/>
+              </a:spcAft>
+              <a:defRPr sz="1100">
+                <a:solidFill>
+                  <a:srgbClr val="232323"/>
+                </a:solidFill>
+              </a:defRPr>
+            </a:pPr>
+            <a:r>
+              <a:t>Business and Sci/Tech overlap because many company stories include technology terms.</a:t>
+            </a:r>
+          </a:p>
+          <a:p>
+            <a:pPr>
+              <a:spcAft>
+                <a:spcPts val="500"/>
+              </a:spcAft>
+              <a:defRPr sz="1100">
+                <a:solidFill>
+                  <a:srgbClr val="232323"/>
+                </a:solidFill>
+              </a:defRPr>
+            </a:pPr>
+            <a:r>
+              <a:t>The pattern is consistent with the selected failure examples.</a:t>
+            </a:r>
+          </a:p>
+        </p:txBody>
+      </p:sp>
+      <p:sp>
+        <p:nvSpPr>
+          <p:cNvPr id="7" name="TextBox 6"/>
+          <p:cNvSpPr txBox="1"/>
+          <p:nvPr/>
+        </p:nvSpPr>
+        <p:spPr>
+          <a:xfrm>
+            <a:off x="109728" y="6565392"/>
+            <a:ext cx="3200400" cy="146304"/>
           </a:xfrm>
           <a:prstGeom prst="rect">
             <a:avLst/>
@@ -5371,96 +6355,28 @@
           <a:lstStyle/>
           <a:p>
             <a:pPr>
-              <a:defRPr sz="2800" b="1">
-                <a:solidFill>
-                  <a:srgbClr val="0B2545"/>
-                </a:solidFill>
-              </a:defRPr>
-            </a:pPr>
-            <a:r>
-              <a:t>Longer context did not help, and errors are semantic boundary cases.</a:t>
-            </a:r>
-          </a:p>
-        </p:txBody>
-      </p:sp>
-      <p:sp>
-        <p:nvSpPr>
-          <p:cNvPr id="4" name="TextBox 3"/>
+              <a:defRPr sz="550">
+                <a:solidFill>
+                  <a:srgbClr val="1F4E79"/>
+                </a:solidFill>
+              </a:defRPr>
+            </a:pPr>
+            <a:r>
+              <a:t>Advanced Battery Manufacturing Systems</a:t>
+            </a:r>
+          </a:p>
+        </p:txBody>
+      </p:sp>
+      <p:sp>
+        <p:nvSpPr>
+          <p:cNvPr id="8" name="TextBox 7"/>
           <p:cNvSpPr txBox="1"/>
           <p:nvPr/>
         </p:nvSpPr>
         <p:spPr>
           <a:xfrm>
-            <a:off x="822960" y="1691640"/>
-            <a:ext cx="10241280" cy="4389120"/>
-          </a:xfrm>
-          <a:prstGeom prst="rect">
-            <a:avLst/>
-          </a:prstGeom>
-          <a:noFill/>
-        </p:spPr>
-        <p:txBody>
-          <a:bodyPr wrap="square">
-            <a:spAutoFit/>
-          </a:bodyPr>
-          <a:lstStyle/>
-          <a:p>
-            <a:pPr>
-              <a:spcAft>
-                <a:spcPts val="800"/>
-              </a:spcAft>
-              <a:defRPr sz="2000">
-                <a:solidFill>
-                  <a:srgbClr val="232323"/>
-                </a:solidFill>
-              </a:defRPr>
-            </a:pPr>
-            <a:r>
-              <a:t>256 tokens reduced validation metrics for both models.</a:t>
-            </a:r>
-          </a:p>
-          <a:p>
-            <a:pPr>
-              <a:spcAft>
-                <a:spcPts val="800"/>
-              </a:spcAft>
-              <a:defRPr sz="2000">
-                <a:solidFill>
-                  <a:srgbClr val="232323"/>
-                </a:solidFill>
-              </a:defRPr>
-            </a:pPr>
-            <a:r>
-              <a:t>Selected errors include Olympics/World ambiguity and Business/Sci-Tech overlap.</a:t>
-            </a:r>
-          </a:p>
-          <a:p>
-            <a:pPr>
-              <a:spcAft>
-                <a:spcPts val="800"/>
-              </a:spcAft>
-              <a:defRPr sz="2000">
-                <a:solidFill>
-                  <a:srgbClr val="232323"/>
-                </a:solidFill>
-              </a:defRPr>
-            </a:pPr>
-            <a:r>
-              <a:t>The models fail similarly on ambiguous section cues but differ on some single-model errors.</a:t>
-            </a:r>
-          </a:p>
-        </p:txBody>
-      </p:sp>
-      <p:sp>
-        <p:nvSpPr>
-          <p:cNvPr id="5" name="TextBox 4"/>
-          <p:cNvSpPr txBox="1"/>
-          <p:nvPr/>
-        </p:nvSpPr>
-        <p:spPr>
-          <a:xfrm>
-            <a:off x="10881360" y="6355080"/>
-            <a:ext cx="640080" cy="182880"/>
+            <a:off x="8412480" y="6565392"/>
+            <a:ext cx="502920" cy="146304"/>
           </a:xfrm>
           <a:prstGeom prst="rect">
             <a:avLst/>
@@ -5474,14 +6390,14 @@
           <a:lstStyle/>
           <a:p>
             <a:pPr algn="r">
-              <a:defRPr sz="800">
+              <a:defRPr sz="550">
                 <a:solidFill>
                   <a:srgbClr val="787878"/>
                 </a:solidFill>
               </a:defRPr>
             </a:pPr>
             <a:r>
-              <a:t>9</a:t>
+              <a:t>9 of 11</a:t>
             </a:r>
           </a:p>
         </p:txBody>

</xml_diff>